<commit_message>
[FEAT]index.html 경매 중단 기능 추가
</commit_message>
<xml_diff>
--- a/NFT경매시스템_발표.pptx
+++ b/NFT경매시스템_발표.pptx
@@ -146,7 +146,7 @@
     </p:spTree>
     <p:extLst>
       <p:ext uri="{BB962C8B-B14F-4D97-AF65-F5344CB8AC3E}">
-        <p14:creationId xmlns:p14="http://schemas.microsoft.com/office/powerpoint/2010/main" val="2190566"/>
+        <p14:creationId xmlns:p14="http://schemas.microsoft.com/office/powerpoint/2010/main" val="2092052037"/>
       </p:ext>
     </p:extLst>
   </p:cSld>
@@ -1637,48 +1637,9 @@
                 <a:ea typeface="Calibri" pitchFamily="34" charset="-122"/>
                 <a:cs typeface="Calibri" pitchFamily="34" charset="-120"/>
               </a:rPr>
-              <a:t>2026. 06. 06</a:t>
+              <a:t>2026. 06. 11</a:t>
             </a:r>
             <a:endParaRPr lang="en-US" sz="1300" dirty="0"/>
-          </a:p>
-        </p:txBody>
-      </p:sp>
-      <p:sp>
-        <p:nvSpPr>
-          <p:cNvPr id="8" name="TextBox 7">
-            <a:extLst>
-              <a:ext uri="{FF2B5EF4-FFF2-40B4-BE49-F238E27FC236}">
-                <a16:creationId xmlns:a16="http://schemas.microsoft.com/office/drawing/2014/main" id="{8E8C4814-B53F-1803-1AB9-FDD619B52CE8}"/>
-              </a:ext>
-            </a:extLst>
-          </p:cNvPr>
-          <p:cNvSpPr txBox="1"/>
-          <p:nvPr/>
-        </p:nvSpPr>
-        <p:spPr>
-          <a:xfrm>
-            <a:off x="3043002" y="3627620"/>
-            <a:ext cx="2263515" cy="369332"/>
-          </a:xfrm>
-          <a:prstGeom prst="rect">
-            <a:avLst/>
-          </a:prstGeom>
-          <a:noFill/>
-        </p:spPr>
-        <p:txBody>
-          <a:bodyPr wrap="square" rtlCol="0">
-            <a:spAutoFit/>
-          </a:bodyPr>
-          <a:lstStyle/>
-          <a:p>
-            <a:r>
-              <a:rPr kumimoji="1" lang="en-US" altLang="ko-KR" dirty="0"/>
-              <a:t>202035106</a:t>
-            </a:r>
-            <a:r>
-              <a:rPr kumimoji="1" lang="ko-KR" altLang="en-US" dirty="0"/>
-              <a:t> 권기범</a:t>
-            </a:r>
           </a:p>
         </p:txBody>
       </p:sp>
@@ -1929,7 +1890,7 @@
                 <a:ea typeface="Calibri" pitchFamily="34" charset="-122"/>
                 <a:cs typeface="Calibri" pitchFamily="34" charset="-120"/>
               </a:rPr>
-              <a:t>✓  ERC-721 기반 NFT 컨트랙트 (mint / approve / transfer)</a:t>
+              <a:t>✓  ERC-721 기반 NFT 컨트랙트</a:t>
             </a:r>
             <a:endParaRPr lang="en-US" sz="1300" dirty="0"/>
           </a:p>
@@ -1968,7 +1929,7 @@
                 <a:ea typeface="Calibri" pitchFamily="34" charset="-122"/>
                 <a:cs typeface="Calibri" pitchFamily="34" charset="-120"/>
               </a:rPr>
-              <a:t>✓  경매 스마트 컨트랙트 (입찰 / 낙찰 / 환불)</a:t>
+              <a:t>✓  경매 컨트랙트 (입찰 / 낙찰 / 판매자 취소 / 환불)</a:t>
             </a:r>
             <a:endParaRPr lang="en-US" sz="1300" dirty="0"/>
           </a:p>
@@ -2007,7 +1968,7 @@
                 <a:ea typeface="Calibri" pitchFamily="34" charset="-122"/>
                 <a:cs typeface="Calibri" pitchFamily="34" charset="-120"/>
               </a:rPr>
-              <a:t>✓  Web3.js 기반 HTML 프론트엔드 + MetaMask 연동</a:t>
+              <a:t>✓  이미지 업로드 + Web3.js 프론트엔드 + MetaMask 연동</a:t>
             </a:r>
             <a:endParaRPr lang="en-US" sz="1300" dirty="0"/>
           </a:p>
@@ -2085,7 +2046,7 @@
                 <a:ea typeface="Calibri" pitchFamily="34" charset="-122"/>
                 <a:cs typeface="Calibri" pitchFamily="34" charset="-120"/>
               </a:rPr>
-              <a:t>→  IPFS 연동으로 NFT 이미지·메타데이터 저장</a:t>
+              <a:t>→  IPFS 연동으로 영구적인 이미지 저장</a:t>
             </a:r>
             <a:endParaRPr lang="en-US" sz="1300" dirty="0"/>
           </a:p>
@@ -2509,7 +2470,7 @@
         <p:spPr>
           <a:xfrm>
             <a:off x="640080" y="1719072"/>
-            <a:ext cx="4572000" cy="274320"/>
+            <a:ext cx="5029200" cy="274320"/>
           </a:xfrm>
           <a:prstGeom prst="rect">
             <a:avLst/>
@@ -2525,7 +2486,7 @@
               <a:buNone/>
             </a:pPr>
             <a:r>
-              <a:rPr lang="en-US" sz="1200" dirty="0">
+              <a:rPr lang="en-US" sz="1100" dirty="0">
                 <a:solidFill>
                   <a:srgbClr val="4A6274"/>
                 </a:solidFill>
@@ -2533,9 +2494,9 @@
                 <a:ea typeface="Calibri" pitchFamily="34" charset="-122"/>
                 <a:cs typeface="Calibri" pitchFamily="34" charset="-120"/>
               </a:rPr>
-              <a:t>HTML + Web3.js + MetaMask</a:t>
-            </a:r>
-            <a:endParaRPr lang="en-US" sz="1200" dirty="0"/>
+              <a:t>HTML + Web3.js + MetaMask  |  Express 파일 서버</a:t>
+            </a:r>
+            <a:endParaRPr lang="en-US" sz="1100" dirty="0"/>
           </a:p>
         </p:txBody>
       </p:sp>
@@ -2547,8 +2508,8 @@
         </p:nvSpPr>
         <p:spPr>
           <a:xfrm>
-            <a:off x="4937760" y="1371600"/>
-            <a:ext cx="3749040" cy="548640"/>
+            <a:off x="5120640" y="1371600"/>
+            <a:ext cx="3566160" cy="548640"/>
           </a:xfrm>
           <a:prstGeom prst="rect">
             <a:avLst/>
@@ -2564,7 +2525,7 @@
               <a:buNone/>
             </a:pPr>
             <a:r>
-              <a:rPr lang="en-US" sz="1200" dirty="0">
+              <a:rPr lang="en-US" sz="1100" dirty="0">
                 <a:solidFill>
                   <a:srgbClr val="4A6274"/>
                 </a:solidFill>
@@ -2572,9 +2533,9 @@
                 <a:ea typeface="Calibri" pitchFamily="34" charset="-122"/>
                 <a:cs typeface="Calibri" pitchFamily="34" charset="-120"/>
               </a:rPr>
-              <a:t>사용자 인터페이스 / 지갑 연결 / 트랜잭션 서명</a:t>
-            </a:r>
-            <a:endParaRPr lang="en-US" sz="1200" dirty="0"/>
+              <a:t>사용자 인터페이스 / 이미지 업로드 / 지갑 연결 / 트랜잭션 서명</a:t>
+            </a:r>
+            <a:endParaRPr lang="en-US" sz="1100" dirty="0"/>
           </a:p>
         </p:txBody>
       </p:sp>
@@ -2736,7 +2697,7 @@
         <p:spPr>
           <a:xfrm>
             <a:off x="640080" y="2999232"/>
-            <a:ext cx="4572000" cy="274320"/>
+            <a:ext cx="5029200" cy="274320"/>
           </a:xfrm>
           <a:prstGeom prst="rect">
             <a:avLst/>
@@ -2752,7 +2713,7 @@
               <a:buNone/>
             </a:pPr>
             <a:r>
-              <a:rPr lang="en-US" sz="1200" dirty="0">
+              <a:rPr lang="en-US" sz="1100" dirty="0">
                 <a:solidFill>
                   <a:srgbClr val="4A6274"/>
                 </a:solidFill>
@@ -2762,7 +2723,7 @@
               </a:rPr>
               <a:t>NFT.sol + Auction.sol (Solidity 0.8.19)</a:t>
             </a:r>
-            <a:endParaRPr lang="en-US" sz="1200" dirty="0"/>
+            <a:endParaRPr lang="en-US" sz="1100" dirty="0"/>
           </a:p>
         </p:txBody>
       </p:sp>
@@ -2774,8 +2735,8 @@
         </p:nvSpPr>
         <p:spPr>
           <a:xfrm>
-            <a:off x="4937760" y="2651760"/>
-            <a:ext cx="3749040" cy="548640"/>
+            <a:off x="5120640" y="2651760"/>
+            <a:ext cx="3566160" cy="548640"/>
           </a:xfrm>
           <a:prstGeom prst="rect">
             <a:avLst/>
@@ -2791,7 +2752,7 @@
               <a:buNone/>
             </a:pPr>
             <a:r>
-              <a:rPr lang="en-US" sz="1200" dirty="0">
+              <a:rPr lang="en-US" sz="1100" dirty="0">
                 <a:solidFill>
                   <a:srgbClr val="4A6274"/>
                 </a:solidFill>
@@ -2799,9 +2760,9 @@
                 <a:ea typeface="Calibri" pitchFamily="34" charset="-122"/>
                 <a:cs typeface="Calibri" pitchFamily="34" charset="-120"/>
               </a:rPr>
-              <a:t>비즈니스 로직 / NFT 발행 / 경매 처리</a:t>
-            </a:r>
-            <a:endParaRPr lang="en-US" sz="1200" dirty="0"/>
+              <a:t>NFT 발행 / 경매 등록·입찰·낙찰·취소 / 환불</a:t>
+            </a:r>
+            <a:endParaRPr lang="en-US" sz="1100" dirty="0"/>
           </a:p>
         </p:txBody>
       </p:sp>
@@ -2963,7 +2924,7 @@
         <p:spPr>
           <a:xfrm>
             <a:off x="640080" y="4279392"/>
-            <a:ext cx="4572000" cy="274320"/>
+            <a:ext cx="5029200" cy="274320"/>
           </a:xfrm>
           <a:prstGeom prst="rect">
             <a:avLst/>
@@ -2979,7 +2940,7 @@
               <a:buNone/>
             </a:pPr>
             <a:r>
-              <a:rPr lang="en-US" sz="1200" dirty="0">
+              <a:rPr lang="en-US" sz="1100" dirty="0">
                 <a:solidFill>
                   <a:srgbClr val="4A6274"/>
                 </a:solidFill>
@@ -2989,7 +2950,7 @@
               </a:rPr>
               <a:t>Geth v1.10  |  Chain ID: 1004</a:t>
             </a:r>
-            <a:endParaRPr lang="en-US" sz="1200" dirty="0"/>
+            <a:endParaRPr lang="en-US" sz="1100" dirty="0"/>
           </a:p>
         </p:txBody>
       </p:sp>
@@ -3001,8 +2962,8 @@
         </p:nvSpPr>
         <p:spPr>
           <a:xfrm>
-            <a:off x="4937760" y="3931920"/>
-            <a:ext cx="3749040" cy="548640"/>
+            <a:off x="5120640" y="3931920"/>
+            <a:ext cx="3566160" cy="548640"/>
           </a:xfrm>
           <a:prstGeom prst="rect">
             <a:avLst/>
@@ -3018,7 +2979,7 @@
               <a:buNone/>
             </a:pPr>
             <a:r>
-              <a:rPr lang="en-US" sz="1200" dirty="0">
+              <a:rPr lang="en-US" sz="1100" dirty="0">
                 <a:solidFill>
                   <a:srgbClr val="4A6274"/>
                 </a:solidFill>
@@ -3028,67 +2989,7 @@
               </a:rPr>
               <a:t>Node1 (8545) 관리자   |   Node2 (8546) 판매자·구매자</a:t>
             </a:r>
-            <a:endParaRPr lang="en-US" sz="1200" dirty="0"/>
-          </a:p>
-        </p:txBody>
-      </p:sp>
-      <p:sp>
-        <p:nvSpPr>
-          <p:cNvPr id="22" name="Shape 20"/>
-          <p:cNvSpPr/>
-          <p:nvPr/>
-        </p:nvSpPr>
-        <p:spPr>
-          <a:xfrm>
-            <a:off x="4389120" y="2194560"/>
-            <a:ext cx="0" cy="182880"/>
-          </a:xfrm>
-          <a:prstGeom prst="line">
-            <a:avLst/>
-          </a:prstGeom>
-          <a:noFill/>
-          <a:ln w="25400">
-            <a:solidFill>
-              <a:srgbClr val="02C39A"/>
-            </a:solidFill>
-            <a:prstDash val="solid"/>
-          </a:ln>
-        </p:spPr>
-        <p:txBody>
-          <a:bodyPr/>
-          <a:lstStyle/>
-          <a:p>
-            <a:endParaRPr lang="ko-KR" altLang="en-US"/>
-          </a:p>
-        </p:txBody>
-      </p:sp>
-      <p:sp>
-        <p:nvSpPr>
-          <p:cNvPr id="23" name="Shape 21"/>
-          <p:cNvSpPr/>
-          <p:nvPr/>
-        </p:nvSpPr>
-        <p:spPr>
-          <a:xfrm>
-            <a:off x="4389120" y="3474720"/>
-            <a:ext cx="0" cy="182880"/>
-          </a:xfrm>
-          <a:prstGeom prst="line">
-            <a:avLst/>
-          </a:prstGeom>
-          <a:noFill/>
-          <a:ln w="25400">
-            <a:solidFill>
-              <a:srgbClr val="02C39A"/>
-            </a:solidFill>
-            <a:prstDash val="solid"/>
-          </a:ln>
-        </p:spPr>
-        <p:txBody>
-          <a:bodyPr/>
-          <a:lstStyle/>
-          <a:p>
-            <a:endParaRPr lang="ko-KR" altLang="en-US"/>
+            <a:endParaRPr lang="en-US" sz="1100" dirty="0"/>
           </a:p>
         </p:txBody>
       </p:sp>
@@ -3417,7 +3318,7 @@
                 <a:ea typeface="Calibri" pitchFamily="34" charset="-122"/>
                 <a:cs typeface="Calibri" pitchFamily="34" charset="-120"/>
               </a:rPr>
-              <a:t>Genesis 설정 → 노드 초기화 → 계정 생성 → 마이닝 시작 → 피어 연결</a:t>
+              <a:t>Genesis 설정 → 노드 초기화 → 계정 생성 → 마이닝 → 피어 연결</a:t>
             </a:r>
             <a:endParaRPr lang="en-US" sz="1200" dirty="0"/>
           </a:p>
@@ -3644,7 +3545,7 @@
                 <a:ea typeface="Calibri" pitchFamily="34" charset="-122"/>
                 <a:cs typeface="Calibri" pitchFamily="34" charset="-120"/>
               </a:rPr>
-              <a:t>컨트랙트 작성(NFT.sol, Auction.sol) → 컴파일 → Node1에 배포</a:t>
+              <a:t>NFT.sol · Auction.sol 작성 → 컴파일 → Node1에 배포</a:t>
             </a:r>
             <a:endParaRPr lang="en-US" sz="1200" dirty="0"/>
           </a:p>
@@ -3871,46 +3772,7 @@
                 <a:ea typeface="Calibri" pitchFamily="34" charset="-122"/>
                 <a:cs typeface="Calibri" pitchFamily="34" charset="-120"/>
               </a:rPr>
-              <a:t>Web3.js 연동 → MetaMask 연결 → 경매 UI 구현 → http-server 구동</a:t>
-            </a:r>
-            <a:endParaRPr lang="en-US" sz="1200" dirty="0"/>
-          </a:p>
-        </p:txBody>
-      </p:sp>
-      <p:sp>
-        <p:nvSpPr>
-          <p:cNvPr id="22" name="Text 20"/>
-          <p:cNvSpPr/>
-          <p:nvPr/>
-        </p:nvSpPr>
-        <p:spPr>
-          <a:xfrm>
-            <a:off x="365760" y="4663440"/>
-            <a:ext cx="8412480" cy="320040"/>
-          </a:xfrm>
-          <a:prstGeom prst="rect">
-            <a:avLst/>
-          </a:prstGeom>
-          <a:noFill/>
-          <a:ln/>
-        </p:spPr>
-        <p:txBody>
-          <a:bodyPr wrap="square" lIns="0" tIns="0" rIns="0" bIns="0" rtlCol="0" anchor="ctr"/>
-          <a:lstStyle/>
-          <a:p>
-            <a:pPr marL="0" indent="0" algn="ctr">
-              <a:buNone/>
-            </a:pPr>
-            <a:r>
-              <a:rPr lang="en-US" sz="1200" i="1" dirty="0">
-                <a:solidFill>
-                  <a:srgbClr val="1C7293"/>
-                </a:solidFill>
-                <a:latin typeface="Calibri" pitchFamily="34" charset="0"/>
-                <a:ea typeface="Calibri" pitchFamily="34" charset="-122"/>
-                <a:cs typeface="Calibri" pitchFamily="34" charset="-120"/>
-              </a:rPr>
-              <a:t>⚠  각 단계는 이전 단계에 직접 의존 — 순서를 반드시 준수해야 합니다</a:t>
+              <a:t>Express 서버 + Web3.js 연동 → MetaMask 연결 → 경매 UI 구현</a:t>
             </a:r>
             <a:endParaRPr lang="en-US" sz="1200" dirty="0"/>
           </a:p>
@@ -4546,7 +4408,7 @@
                 <a:ea typeface="Consolas" pitchFamily="34" charset="-122"/>
                 <a:cs typeface="Consolas" pitchFamily="34" charset="-120"/>
               </a:rPr>
-              <a:t>0xe6812126e42b788ac514c11a608e8aea5a8aaba5</a:t>
+              <a:t>판매자: 0xe6812126e42b788ac514c11a608e8aea5a8aaba5</a:t>
             </a:r>
             <a:endParaRPr lang="en-US" sz="950" dirty="0"/>
           </a:p>
@@ -4563,7 +4425,7 @@
                 <a:ea typeface="Consolas" pitchFamily="34" charset="-122"/>
                 <a:cs typeface="Consolas" pitchFamily="34" charset="-120"/>
               </a:rPr>
-              <a:t>0x772fec64fc02614922c9dcfbaf7b0e5eed293e48</a:t>
+              <a:t>구매자: 0x772fec64fc02614922c9dcfbaf7b0e5eed293e48</a:t>
             </a:r>
             <a:endParaRPr lang="en-US" sz="950" dirty="0"/>
           </a:p>
@@ -4571,37 +4433,7 @@
       </p:sp>
       <p:sp>
         <p:nvSpPr>
-          <p:cNvPr id="18" name="Shape 16"/>
-          <p:cNvSpPr/>
-          <p:nvPr/>
-        </p:nvSpPr>
-        <p:spPr>
-          <a:xfrm>
-            <a:off x="4480560" y="3337560"/>
-            <a:ext cx="182880" cy="0"/>
-          </a:xfrm>
-          <a:prstGeom prst="line">
-            <a:avLst/>
-          </a:prstGeom>
-          <a:noFill/>
-          <a:ln w="31750">
-            <a:solidFill>
-              <a:srgbClr val="02C39A"/>
-            </a:solidFill>
-            <a:prstDash val="solid"/>
-          </a:ln>
-        </p:spPr>
-        <p:txBody>
-          <a:bodyPr/>
-          <a:lstStyle/>
-          <a:p>
-            <a:endParaRPr lang="ko-KR" altLang="en-US"/>
-          </a:p>
-        </p:txBody>
-      </p:sp>
-      <p:sp>
-        <p:nvSpPr>
-          <p:cNvPr id="19" name="Text 17"/>
+          <p:cNvPr id="18" name="Text 16"/>
           <p:cNvSpPr/>
           <p:nvPr/>
         </p:nvSpPr>
@@ -4751,7 +4583,7 @@
         <p:spPr>
           <a:xfrm>
             <a:off x="365760" y="1005840"/>
-            <a:ext cx="4206240" cy="3886200"/>
+            <a:ext cx="4206240" cy="2706624"/>
           </a:xfrm>
           <a:prstGeom prst="rect">
             <a:avLst/>
@@ -4900,7 +4732,7 @@
         <p:spPr>
           <a:xfrm>
             <a:off x="548640" y="1691640"/>
-            <a:ext cx="3840480" cy="658368"/>
+            <a:ext cx="3840480" cy="566928"/>
           </a:xfrm>
           <a:prstGeom prst="rect">
             <a:avLst/>
@@ -4931,8 +4763,8 @@
         </p:nvSpPr>
         <p:spPr>
           <a:xfrm>
-            <a:off x="685800" y="1728216"/>
-            <a:ext cx="3566160" cy="274320"/>
+            <a:off x="685800" y="1719072"/>
+            <a:ext cx="3566160" cy="256032"/>
           </a:xfrm>
           <a:prstGeom prst="rect">
             <a:avLst/>
@@ -4948,7 +4780,7 @@
               <a:buNone/>
             </a:pPr>
             <a:r>
-              <a:rPr lang="en-US" sz="1050" b="1" dirty="0">
+              <a:rPr lang="en-US" sz="1000" b="1" dirty="0">
                 <a:solidFill>
                   <a:srgbClr val="1C7293"/>
                 </a:solidFill>
@@ -4958,7 +4790,7 @@
               </a:rPr>
               <a:t>mint(to, uri)</a:t>
             </a:r>
-            <a:endParaRPr lang="en-US" sz="1050" dirty="0"/>
+            <a:endParaRPr lang="en-US" sz="1000" dirty="0"/>
           </a:p>
         </p:txBody>
       </p:sp>
@@ -4970,8 +4802,8 @@
         </p:nvSpPr>
         <p:spPr>
           <a:xfrm>
-            <a:off x="685800" y="2011680"/>
-            <a:ext cx="3566160" cy="274320"/>
+            <a:off x="685800" y="1984248"/>
+            <a:ext cx="3566160" cy="237744"/>
           </a:xfrm>
           <a:prstGeom prst="rect">
             <a:avLst/>
@@ -4987,7 +4819,7 @@
               <a:buNone/>
             </a:pPr>
             <a:r>
-              <a:rPr lang="en-US" sz="1100" dirty="0">
+              <a:rPr lang="en-US" sz="1050" dirty="0">
                 <a:solidFill>
                   <a:srgbClr val="4A6274"/>
                 </a:solidFill>
@@ -4997,7 +4829,7 @@
               </a:rPr>
               <a:t>NFT 발행 → Token ID 반환</a:t>
             </a:r>
-            <a:endParaRPr lang="en-US" sz="1100" dirty="0"/>
+            <a:endParaRPr lang="en-US" sz="1050" dirty="0"/>
           </a:p>
         </p:txBody>
       </p:sp>
@@ -5009,8 +4841,8 @@
         </p:nvSpPr>
         <p:spPr>
           <a:xfrm>
-            <a:off x="548640" y="2468880"/>
-            <a:ext cx="3840480" cy="658368"/>
+            <a:off x="548640" y="2350008"/>
+            <a:ext cx="3840480" cy="566928"/>
           </a:xfrm>
           <a:prstGeom prst="rect">
             <a:avLst/>
@@ -5041,8 +4873,8 @@
         </p:nvSpPr>
         <p:spPr>
           <a:xfrm>
-            <a:off x="685800" y="2505456"/>
-            <a:ext cx="3566160" cy="274320"/>
+            <a:off x="685800" y="2377440"/>
+            <a:ext cx="3566160" cy="256032"/>
           </a:xfrm>
           <a:prstGeom prst="rect">
             <a:avLst/>
@@ -5058,7 +4890,7 @@
               <a:buNone/>
             </a:pPr>
             <a:r>
-              <a:rPr lang="en-US" sz="1050" b="1" dirty="0">
+              <a:rPr lang="en-US" sz="1000" b="1" dirty="0">
                 <a:solidFill>
                   <a:srgbClr val="1C7293"/>
                 </a:solidFill>
@@ -5068,7 +4900,7 @@
               </a:rPr>
               <a:t>approve(to, tokenId)</a:t>
             </a:r>
-            <a:endParaRPr lang="en-US" sz="1050" dirty="0"/>
+            <a:endParaRPr lang="en-US" sz="1000" dirty="0"/>
           </a:p>
         </p:txBody>
       </p:sp>
@@ -5080,8 +4912,8 @@
         </p:nvSpPr>
         <p:spPr>
           <a:xfrm>
-            <a:off x="685800" y="2788920"/>
-            <a:ext cx="3566160" cy="274320"/>
+            <a:off x="685800" y="2642616"/>
+            <a:ext cx="3566160" cy="237744"/>
           </a:xfrm>
           <a:prstGeom prst="rect">
             <a:avLst/>
@@ -5097,7 +4929,7 @@
               <a:buNone/>
             </a:pPr>
             <a:r>
-              <a:rPr lang="en-US" sz="1100" dirty="0">
+              <a:rPr lang="en-US" sz="1050" dirty="0">
                 <a:solidFill>
                   <a:srgbClr val="4A6274"/>
                 </a:solidFill>
@@ -5107,7 +4939,7 @@
               </a:rPr>
               <a:t>경매 컨트랙트에 사용 권한 부여</a:t>
             </a:r>
-            <a:endParaRPr lang="en-US" sz="1100" dirty="0"/>
+            <a:endParaRPr lang="en-US" sz="1050" dirty="0"/>
           </a:p>
         </p:txBody>
       </p:sp>
@@ -5119,8 +4951,8 @@
         </p:nvSpPr>
         <p:spPr>
           <a:xfrm>
-            <a:off x="548640" y="3246120"/>
-            <a:ext cx="3840480" cy="658368"/>
+            <a:off x="548640" y="3008376"/>
+            <a:ext cx="3840480" cy="566928"/>
           </a:xfrm>
           <a:prstGeom prst="rect">
             <a:avLst/>
@@ -5151,8 +4983,8 @@
         </p:nvSpPr>
         <p:spPr>
           <a:xfrm>
-            <a:off x="685800" y="3282696"/>
-            <a:ext cx="3566160" cy="274320"/>
+            <a:off x="685800" y="3035808"/>
+            <a:ext cx="3566160" cy="256032"/>
           </a:xfrm>
           <a:prstGeom prst="rect">
             <a:avLst/>
@@ -5168,7 +5000,7 @@
               <a:buNone/>
             </a:pPr>
             <a:r>
-              <a:rPr lang="en-US" sz="1050" b="1" dirty="0">
+              <a:rPr lang="en-US" sz="1000" b="1" dirty="0">
                 <a:solidFill>
                   <a:srgbClr val="1C7293"/>
                 </a:solidFill>
@@ -5178,7 +5010,7 @@
               </a:rPr>
               <a:t>transferFrom(from, to, tokenId)</a:t>
             </a:r>
-            <a:endParaRPr lang="en-US" sz="1050" dirty="0"/>
+            <a:endParaRPr lang="en-US" sz="1000" dirty="0"/>
           </a:p>
         </p:txBody>
       </p:sp>
@@ -5190,8 +5022,8 @@
         </p:nvSpPr>
         <p:spPr>
           <a:xfrm>
-            <a:off x="685800" y="3566160"/>
-            <a:ext cx="3566160" cy="274320"/>
+            <a:off x="685800" y="3300984"/>
+            <a:ext cx="3566160" cy="237744"/>
           </a:xfrm>
           <a:prstGeom prst="rect">
             <a:avLst/>
@@ -5207,7 +5039,7 @@
               <a:buNone/>
             </a:pPr>
             <a:r>
-              <a:rPr lang="en-US" sz="1100" dirty="0">
+              <a:rPr lang="en-US" sz="1050" dirty="0">
                 <a:solidFill>
                   <a:srgbClr val="4A6274"/>
                 </a:solidFill>
@@ -5217,7 +5049,7 @@
               </a:rPr>
               <a:t>NFT 소유권 이전</a:t>
             </a:r>
-            <a:endParaRPr lang="en-US" sz="1100" dirty="0"/>
+            <a:endParaRPr lang="en-US" sz="1050" dirty="0"/>
           </a:p>
         </p:txBody>
       </p:sp>
@@ -5230,7 +5062,7 @@
         <p:spPr>
           <a:xfrm>
             <a:off x="4754880" y="1005840"/>
-            <a:ext cx="4206240" cy="3886200"/>
+            <a:ext cx="4206240" cy="4023360"/>
           </a:xfrm>
           <a:prstGeom prst="rect">
             <a:avLst/>
@@ -5379,7 +5211,7 @@
         <p:spPr>
           <a:xfrm>
             <a:off x="4937760" y="1691640"/>
-            <a:ext cx="3840480" cy="658368"/>
+            <a:ext cx="3840480" cy="566928"/>
           </a:xfrm>
           <a:prstGeom prst="rect">
             <a:avLst/>
@@ -5410,8 +5242,8 @@
         </p:nvSpPr>
         <p:spPr>
           <a:xfrm>
-            <a:off x="5074920" y="1728216"/>
-            <a:ext cx="3566160" cy="274320"/>
+            <a:off x="5074920" y="1719072"/>
+            <a:ext cx="3566160" cy="256032"/>
           </a:xfrm>
           <a:prstGeom prst="rect">
             <a:avLst/>
@@ -5427,7 +5259,7 @@
               <a:buNone/>
             </a:pPr>
             <a:r>
-              <a:rPr lang="en-US" sz="1050" b="1" dirty="0">
+              <a:rPr lang="en-US" sz="1000" b="1" dirty="0">
                 <a:solidFill>
                   <a:srgbClr val="02C39A"/>
                 </a:solidFill>
@@ -5437,7 +5269,7 @@
               </a:rPr>
               <a:t>createAuction(tokenId, price, dur)</a:t>
             </a:r>
-            <a:endParaRPr lang="en-US" sz="1050" dirty="0"/>
+            <a:endParaRPr lang="en-US" sz="1000" dirty="0"/>
           </a:p>
         </p:txBody>
       </p:sp>
@@ -5449,8 +5281,8 @@
         </p:nvSpPr>
         <p:spPr>
           <a:xfrm>
-            <a:off x="5074920" y="2011680"/>
-            <a:ext cx="3566160" cy="274320"/>
+            <a:off x="5074920" y="1984248"/>
+            <a:ext cx="3566160" cy="237744"/>
           </a:xfrm>
           <a:prstGeom prst="rect">
             <a:avLst/>
@@ -5466,7 +5298,7 @@
               <a:buNone/>
             </a:pPr>
             <a:r>
-              <a:rPr lang="en-US" sz="1100" dirty="0">
+              <a:rPr lang="en-US" sz="1050" dirty="0">
                 <a:solidFill>
                   <a:srgbClr val="4A6274"/>
                 </a:solidFill>
@@ -5476,7 +5308,7 @@
               </a:rPr>
               <a:t>경매 등록</a:t>
             </a:r>
-            <a:endParaRPr lang="en-US" sz="1100" dirty="0"/>
+            <a:endParaRPr lang="en-US" sz="1050" dirty="0"/>
           </a:p>
         </p:txBody>
       </p:sp>
@@ -5488,8 +5320,8 @@
         </p:nvSpPr>
         <p:spPr>
           <a:xfrm>
-            <a:off x="4937760" y="2468880"/>
-            <a:ext cx="3840480" cy="658368"/>
+            <a:off x="4937760" y="2350008"/>
+            <a:ext cx="3840480" cy="566928"/>
           </a:xfrm>
           <a:prstGeom prst="rect">
             <a:avLst/>
@@ -5520,8 +5352,8 @@
         </p:nvSpPr>
         <p:spPr>
           <a:xfrm>
-            <a:off x="5074920" y="2505456"/>
-            <a:ext cx="3566160" cy="274320"/>
+            <a:off x="5074920" y="2377440"/>
+            <a:ext cx="3566160" cy="256032"/>
           </a:xfrm>
           <a:prstGeom prst="rect">
             <a:avLst/>
@@ -5537,7 +5369,7 @@
               <a:buNone/>
             </a:pPr>
             <a:r>
-              <a:rPr lang="en-US" sz="1050" b="1" dirty="0">
+              <a:rPr lang="en-US" sz="1000" b="1" dirty="0">
                 <a:solidFill>
                   <a:srgbClr val="02C39A"/>
                 </a:solidFill>
@@ -5547,7 +5379,7 @@
               </a:rPr>
               <a:t>bid(auctionId)</a:t>
             </a:r>
-            <a:endParaRPr lang="en-US" sz="1050" dirty="0"/>
+            <a:endParaRPr lang="en-US" sz="1000" dirty="0"/>
           </a:p>
         </p:txBody>
       </p:sp>
@@ -5559,8 +5391,8 @@
         </p:nvSpPr>
         <p:spPr>
           <a:xfrm>
-            <a:off x="5074920" y="2788920"/>
-            <a:ext cx="3566160" cy="274320"/>
+            <a:off x="5074920" y="2642616"/>
+            <a:ext cx="3566160" cy="237744"/>
           </a:xfrm>
           <a:prstGeom prst="rect">
             <a:avLst/>
@@ -5576,7 +5408,7 @@
               <a:buNone/>
             </a:pPr>
             <a:r>
-              <a:rPr lang="en-US" sz="1100" dirty="0">
+              <a:rPr lang="en-US" sz="1050" dirty="0">
                 <a:solidFill>
                   <a:srgbClr val="4A6274"/>
                 </a:solidFill>
@@ -5586,7 +5418,7 @@
               </a:rPr>
               <a:t>입찰  (ETH payable)</a:t>
             </a:r>
-            <a:endParaRPr lang="en-US" sz="1100" dirty="0"/>
+            <a:endParaRPr lang="en-US" sz="1050" dirty="0"/>
           </a:p>
         </p:txBody>
       </p:sp>
@@ -5598,8 +5430,8 @@
         </p:nvSpPr>
         <p:spPr>
           <a:xfrm>
-            <a:off x="4937760" y="3246120"/>
-            <a:ext cx="3840480" cy="658368"/>
+            <a:off x="4937760" y="3008376"/>
+            <a:ext cx="3840480" cy="566928"/>
           </a:xfrm>
           <a:prstGeom prst="rect">
             <a:avLst/>
@@ -5630,8 +5462,8 @@
         </p:nvSpPr>
         <p:spPr>
           <a:xfrm>
-            <a:off x="5074920" y="3282696"/>
-            <a:ext cx="3566160" cy="274320"/>
+            <a:off x="5074920" y="3035808"/>
+            <a:ext cx="3566160" cy="256032"/>
           </a:xfrm>
           <a:prstGeom prst="rect">
             <a:avLst/>
@@ -5647,7 +5479,7 @@
               <a:buNone/>
             </a:pPr>
             <a:r>
-              <a:rPr lang="en-US" sz="1050" b="1" dirty="0">
+              <a:rPr lang="en-US" sz="1000" b="1" dirty="0">
                 <a:solidFill>
                   <a:srgbClr val="02C39A"/>
                 </a:solidFill>
@@ -5657,7 +5489,7 @@
               </a:rPr>
               <a:t>endAuction(auctionId)</a:t>
             </a:r>
-            <a:endParaRPr lang="en-US" sz="1050" dirty="0"/>
+            <a:endParaRPr lang="en-US" sz="1000" dirty="0"/>
           </a:p>
         </p:txBody>
       </p:sp>
@@ -5669,8 +5501,8 @@
         </p:nvSpPr>
         <p:spPr>
           <a:xfrm>
-            <a:off x="5074920" y="3566160"/>
-            <a:ext cx="3566160" cy="274320"/>
+            <a:off x="5074920" y="3300984"/>
+            <a:ext cx="3566160" cy="237744"/>
           </a:xfrm>
           <a:prstGeom prst="rect">
             <a:avLst/>
@@ -5686,7 +5518,7 @@
               <a:buNone/>
             </a:pPr>
             <a:r>
-              <a:rPr lang="en-US" sz="1100" dirty="0">
+              <a:rPr lang="en-US" sz="1050" dirty="0">
                 <a:solidFill>
                   <a:srgbClr val="4A6274"/>
                 </a:solidFill>
@@ -5696,7 +5528,7 @@
               </a:rPr>
               <a:t>낙찰 처리 (NFT → 구매자, ETH → 판매자)</a:t>
             </a:r>
-            <a:endParaRPr lang="en-US" sz="1100" dirty="0"/>
+            <a:endParaRPr lang="en-US" sz="1050" dirty="0"/>
           </a:p>
         </p:txBody>
       </p:sp>
@@ -5708,8 +5540,8 @@
         </p:nvSpPr>
         <p:spPr>
           <a:xfrm>
-            <a:off x="4937760" y="4023360"/>
-            <a:ext cx="3840480" cy="658368"/>
+            <a:off x="4937760" y="3666744"/>
+            <a:ext cx="3840480" cy="566928"/>
           </a:xfrm>
           <a:prstGeom prst="rect">
             <a:avLst/>
@@ -5740,8 +5572,8 @@
         </p:nvSpPr>
         <p:spPr>
           <a:xfrm>
-            <a:off x="5074920" y="4059936"/>
-            <a:ext cx="3566160" cy="274320"/>
+            <a:off x="5074920" y="3694176"/>
+            <a:ext cx="3566160" cy="256032"/>
           </a:xfrm>
           <a:prstGeom prst="rect">
             <a:avLst/>
@@ -5757,7 +5589,7 @@
               <a:buNone/>
             </a:pPr>
             <a:r>
-              <a:rPr lang="en-US" sz="1050" b="1" dirty="0">
+              <a:rPr lang="en-US" sz="1000" b="1" dirty="0">
                 <a:solidFill>
                   <a:srgbClr val="02C39A"/>
                 </a:solidFill>
@@ -5765,9 +5597,9 @@
                 <a:ea typeface="Consolas" pitchFamily="34" charset="-122"/>
                 <a:cs typeface="Consolas" pitchFamily="34" charset="-120"/>
               </a:rPr>
-              <a:t>withdraw(auctionId)</a:t>
-            </a:r>
-            <a:endParaRPr lang="en-US" sz="1050" dirty="0"/>
+              <a:t>cancelAuction(auctionId)</a:t>
+            </a:r>
+            <a:endParaRPr lang="en-US" sz="1000" dirty="0"/>
           </a:p>
         </p:txBody>
       </p:sp>
@@ -5779,8 +5611,8 @@
         </p:nvSpPr>
         <p:spPr>
           <a:xfrm>
-            <a:off x="5074920" y="4343400"/>
-            <a:ext cx="3566160" cy="274320"/>
+            <a:off x="5074920" y="3959352"/>
+            <a:ext cx="3566160" cy="237744"/>
           </a:xfrm>
           <a:prstGeom prst="rect">
             <a:avLst/>
@@ -5796,7 +5628,7 @@
               <a:buNone/>
             </a:pPr>
             <a:r>
-              <a:rPr lang="en-US" sz="1100" dirty="0">
+              <a:rPr lang="en-US" sz="1050" dirty="0">
                 <a:solidFill>
                   <a:srgbClr val="4A6274"/>
                 </a:solidFill>
@@ -5804,9 +5636,119 @@
                 <a:ea typeface="Calibri" pitchFamily="34" charset="-122"/>
                 <a:cs typeface="Calibri" pitchFamily="34" charset="-120"/>
               </a:rPr>
+              <a:t>판매자 전용 강제 취소 + 즉시 환불</a:t>
+            </a:r>
+            <a:endParaRPr lang="en-US" sz="1050" dirty="0"/>
+          </a:p>
+        </p:txBody>
+      </p:sp>
+      <p:sp>
+        <p:nvSpPr>
+          <p:cNvPr id="33" name="Shape 31"/>
+          <p:cNvSpPr/>
+          <p:nvPr/>
+        </p:nvSpPr>
+        <p:spPr>
+          <a:xfrm>
+            <a:off x="4937760" y="4325112"/>
+            <a:ext cx="3840480" cy="566928"/>
+          </a:xfrm>
+          <a:prstGeom prst="rect">
+            <a:avLst/>
+          </a:prstGeom>
+          <a:solidFill>
+            <a:srgbClr val="EAF4FB"/>
+          </a:solidFill>
+          <a:ln w="12700">
+            <a:solidFill>
+              <a:srgbClr val="D0E8F5"/>
+            </a:solidFill>
+            <a:prstDash val="solid"/>
+          </a:ln>
+        </p:spPr>
+        <p:txBody>
+          <a:bodyPr/>
+          <a:lstStyle/>
+          <a:p>
+            <a:endParaRPr lang="ko-KR" altLang="en-US"/>
+          </a:p>
+        </p:txBody>
+      </p:sp>
+      <p:sp>
+        <p:nvSpPr>
+          <p:cNvPr id="34" name="Text 32"/>
+          <p:cNvSpPr/>
+          <p:nvPr/>
+        </p:nvSpPr>
+        <p:spPr>
+          <a:xfrm>
+            <a:off x="5074920" y="4352544"/>
+            <a:ext cx="3566160" cy="256032"/>
+          </a:xfrm>
+          <a:prstGeom prst="rect">
+            <a:avLst/>
+          </a:prstGeom>
+          <a:noFill/>
+          <a:ln/>
+        </p:spPr>
+        <p:txBody>
+          <a:bodyPr wrap="square" lIns="0" tIns="0" rIns="0" bIns="0" rtlCol="0" anchor="ctr"/>
+          <a:lstStyle/>
+          <a:p>
+            <a:pPr marL="0" indent="0">
+              <a:buNone/>
+            </a:pPr>
+            <a:r>
+              <a:rPr lang="en-US" sz="1000" b="1" dirty="0">
+                <a:solidFill>
+                  <a:srgbClr val="02C39A"/>
+                </a:solidFill>
+                <a:latin typeface="Consolas" pitchFamily="34" charset="0"/>
+                <a:ea typeface="Consolas" pitchFamily="34" charset="-122"/>
+                <a:cs typeface="Consolas" pitchFamily="34" charset="-120"/>
+              </a:rPr>
+              <a:t>withdraw(auctionId)</a:t>
+            </a:r>
+            <a:endParaRPr lang="en-US" sz="1000" dirty="0"/>
+          </a:p>
+        </p:txBody>
+      </p:sp>
+      <p:sp>
+        <p:nvSpPr>
+          <p:cNvPr id="35" name="Text 33"/>
+          <p:cNvSpPr/>
+          <p:nvPr/>
+        </p:nvSpPr>
+        <p:spPr>
+          <a:xfrm>
+            <a:off x="5074920" y="4617720"/>
+            <a:ext cx="3566160" cy="237744"/>
+          </a:xfrm>
+          <a:prstGeom prst="rect">
+            <a:avLst/>
+          </a:prstGeom>
+          <a:noFill/>
+          <a:ln/>
+        </p:spPr>
+        <p:txBody>
+          <a:bodyPr wrap="square" lIns="0" tIns="0" rIns="0" bIns="0" rtlCol="0" anchor="ctr"/>
+          <a:lstStyle/>
+          <a:p>
+            <a:pPr marL="0" indent="0">
+              <a:buNone/>
+            </a:pPr>
+            <a:r>
+              <a:rPr lang="en-US" sz="1050" dirty="0">
+                <a:solidFill>
+                  <a:srgbClr val="4A6274"/>
+                </a:solidFill>
+                <a:latin typeface="Calibri" pitchFamily="34" charset="0"/>
+                <a:ea typeface="Calibri" pitchFamily="34" charset="-122"/>
+                <a:cs typeface="Calibri" pitchFamily="34" charset="-120"/>
+              </a:rPr>
               <a:t>환불  (낙찰 실패 입찰자)</a:t>
             </a:r>
-            <a:endParaRPr lang="en-US" sz="1100" dirty="0"/>
+            <a:endParaRPr lang="en-US" sz="1050" dirty="0"/>
           </a:p>
         </p:txBody>
       </p:sp>
@@ -6241,7 +6183,7 @@
                 <a:ea typeface="Calibri" pitchFamily="34" charset="-122"/>
                 <a:cs typeface="Calibri" pitchFamily="34" charset="-120"/>
               </a:rPr>
-              <a:t>3. 배포 결과 ABI + 주소 → Frontend에서 사용</a:t>
+              <a:t>3. 배포 결과 ABI + 주소 → Frontend 적용</a:t>
             </a:r>
             <a:endParaRPr lang="en-US" sz="1150" dirty="0"/>
           </a:p>
@@ -6280,7 +6222,7 @@
                 <a:ea typeface="Arial Black" pitchFamily="34" charset="-122"/>
                 <a:cs typeface="Arial Black" pitchFamily="34" charset="-120"/>
               </a:rPr>
-              <a:t>배포 결과</a:t>
+              <a:t>최종 배포 결과 (재배포 포함)</a:t>
             </a:r>
             <a:endParaRPr lang="en-US" sz="1600" dirty="0"/>
           </a:p>
@@ -6429,7 +6371,7 @@
                 <a:ea typeface="Consolas" pitchFamily="34" charset="-122"/>
                 <a:cs typeface="Consolas" pitchFamily="34" charset="-120"/>
               </a:rPr>
-              <a:t>0x4AA3f6B8545b9AFdF753CAcC13e5a03f5D7D25A0</a:t>
+              <a:t>0xe040Ef325C3d21Cf23d2c1Ed90119343558e9b80</a:t>
             </a:r>
             <a:endParaRPr lang="en-US" sz="1000" dirty="0"/>
           </a:p>
@@ -6617,7 +6559,7 @@
                 <a:ea typeface="Consolas" pitchFamily="34" charset="-122"/>
                 <a:cs typeface="Consolas" pitchFamily="34" charset="-120"/>
               </a:rPr>
-              <a:t>0x34D6CB19d1707a4036323dd190485c87D8DE792b</a:t>
+              <a:t>0xDdCcBa448952Ff6D395746E971481a0b4bc546C8</a:t>
             </a:r>
             <a:endParaRPr lang="en-US" sz="1000" dirty="0"/>
           </a:p>
@@ -6656,7 +6598,7 @@
                 <a:ea typeface="Calibri" pitchFamily="34" charset="-122"/>
                 <a:cs typeface="Calibri" pitchFamily="34" charset="-120"/>
               </a:rPr>
-              <a:t>1,361,947 gas</a:t>
+              <a:t>1,578,524 gas</a:t>
             </a:r>
             <a:endParaRPr lang="en-US" sz="1100" dirty="0"/>
           </a:p>
@@ -6687,7 +6629,7 @@
               <a:buNone/>
             </a:pPr>
             <a:r>
-              <a:rPr lang="en-US" sz="1200" i="1" dirty="0">
+              <a:rPr lang="en-US" sz="1100" i="1" dirty="0">
                 <a:solidFill>
                   <a:srgbClr val="4A6274"/>
                 </a:solidFill>
@@ -6695,9 +6637,9 @@
                 <a:ea typeface="Calibri" pitchFamily="34" charset="-122"/>
                 <a:cs typeface="Calibri" pitchFamily="34" charset="-120"/>
               </a:rPr>
-              <a:t>총 배포 비용: 0.002468862 ETH  |  배포 계정: Node1 관리자</a:t>
-            </a:r>
-            <a:endParaRPr lang="en-US" sz="1200" dirty="0"/>
+              <a:t>총 배포 비용: 0.002685439 ETH  |  배포 계정: Node1 관리자  |  cancelAuction 추가로 인해 재배포 수행</a:t>
+            </a:r>
+            <a:endParaRPr lang="en-US" sz="1100" dirty="0"/>
           </a:p>
         </p:txBody>
       </p:sp>
@@ -6862,7 +6804,7 @@
               <a:buNone/>
             </a:pPr>
             <a:r>
-              <a:rPr lang="en-US" sz="1200" b="1" dirty="0">
+              <a:rPr lang="en-US" sz="1150" b="1" dirty="0">
                 <a:solidFill>
                   <a:srgbClr val="02C39A"/>
                 </a:solidFill>
@@ -6872,7 +6814,7 @@
               </a:rPr>
               <a:t>Web3.js 1.10.0</a:t>
             </a:r>
-            <a:endParaRPr lang="en-US" sz="1200" dirty="0"/>
+            <a:endParaRPr lang="en-US" sz="1150" dirty="0"/>
           </a:p>
         </p:txBody>
       </p:sp>
@@ -6933,7 +6875,7 @@
               <a:buNone/>
             </a:pPr>
             <a:r>
-              <a:rPr lang="en-US" sz="1200" b="1" dirty="0">
+              <a:rPr lang="en-US" sz="1150" b="1" dirty="0">
                 <a:solidFill>
                   <a:srgbClr val="02C39A"/>
                 </a:solidFill>
@@ -6943,7 +6885,7 @@
               </a:rPr>
               <a:t>MetaMask</a:t>
             </a:r>
-            <a:endParaRPr lang="en-US" sz="1200" dirty="0"/>
+            <a:endParaRPr lang="en-US" sz="1150" dirty="0"/>
           </a:p>
         </p:txBody>
       </p:sp>
@@ -7004,7 +6946,7 @@
               <a:buNone/>
             </a:pPr>
             <a:r>
-              <a:rPr lang="en-US" sz="1200" b="1" dirty="0">
+              <a:rPr lang="en-US" sz="1150" b="1" dirty="0">
                 <a:solidFill>
                   <a:srgbClr val="02C39A"/>
                 </a:solidFill>
@@ -7012,9 +6954,9 @@
                 <a:ea typeface="Consolas" pitchFamily="34" charset="-122"/>
                 <a:cs typeface="Consolas" pitchFamily="34" charset="-120"/>
               </a:rPr>
-              <a:t>HTML5</a:t>
-            </a:r>
-            <a:endParaRPr lang="en-US" sz="1200" dirty="0"/>
+              <a:t>Express.js</a:t>
+            </a:r>
+            <a:endParaRPr lang="en-US" sz="1150" dirty="0"/>
           </a:p>
         </p:txBody>
       </p:sp>
@@ -7075,7 +7017,7 @@
               <a:buNone/>
             </a:pPr>
             <a:r>
-              <a:rPr lang="en-US" sz="1200" b="1" dirty="0">
+              <a:rPr lang="en-US" sz="1150" b="1" dirty="0">
                 <a:solidFill>
                   <a:srgbClr val="02C39A"/>
                 </a:solidFill>
@@ -7083,9 +7025,9 @@
                 <a:ea typeface="Consolas" pitchFamily="34" charset="-122"/>
                 <a:cs typeface="Consolas" pitchFamily="34" charset="-120"/>
               </a:rPr>
-              <a:t>http-server</a:t>
-            </a:r>
-            <a:endParaRPr lang="en-US" sz="1200" dirty="0"/>
+              <a:t>Multer (파일 업로드)</a:t>
+            </a:r>
+            <a:endParaRPr lang="en-US" sz="1150" dirty="0"/>
           </a:p>
         </p:txBody>
       </p:sp>
@@ -7476,7 +7418,7 @@
                 <a:ea typeface="Calibri" pitchFamily="34" charset="-122"/>
                 <a:cs typeface="Calibri" pitchFamily="34" charset="-120"/>
               </a:rPr>
-              <a:t>mint(to, uri)</a:t>
+              <a:t>이미지 업로드 후</a:t>
             </a:r>
             <a:endParaRPr lang="en-US" sz="1100" dirty="0"/>
           </a:p>
@@ -7493,7 +7435,7 @@
                 <a:ea typeface="Calibri" pitchFamily="34" charset="-122"/>
                 <a:cs typeface="Calibri" pitchFamily="34" charset="-120"/>
               </a:rPr>
-              <a:t>판매자 계정으로 호출</a:t>
+              <a:t>mint(to, uri) 호출</a:t>
             </a:r>
             <a:endParaRPr lang="en-US" sz="1100" dirty="0"/>
           </a:p>
@@ -8052,7 +7994,7 @@
                 <a:ea typeface="Arial Black" pitchFamily="34" charset="-122"/>
                 <a:cs typeface="Arial Black" pitchFamily="34" charset="-120"/>
               </a:rPr>
-              <a:t>경매 종료/환불</a:t>
+              <a:t>종료/취소/환불</a:t>
             </a:r>
             <a:endParaRPr lang="en-US" sz="1400" dirty="0"/>
           </a:p>
@@ -8091,7 +8033,7 @@
                 <a:ea typeface="Calibri" pitchFamily="34" charset="-122"/>
                 <a:cs typeface="Calibri" pitchFamily="34" charset="-120"/>
               </a:rPr>
-              <a:t>endAuction / withdraw</a:t>
+              <a:t>endAuction · cancelAuction</a:t>
             </a:r>
             <a:endParaRPr lang="en-US" sz="1100" dirty="0"/>
           </a:p>
@@ -8108,7 +8050,7 @@
                 <a:ea typeface="Calibri" pitchFamily="34" charset="-122"/>
                 <a:cs typeface="Calibri" pitchFamily="34" charset="-120"/>
               </a:rPr>
-              <a:t>누구든 호출 가능</a:t>
+              <a:t>withdraw</a:t>
             </a:r>
             <a:endParaRPr lang="en-US" sz="1100" dirty="0"/>
           </a:p>
@@ -8296,7 +8238,7 @@
                 <a:ea typeface="Calibri" pitchFamily="34" charset="-122"/>
                 <a:cs typeface="Calibri" pitchFamily="34" charset="-120"/>
               </a:rPr>
-              <a:t>읽기 전용 call</a:t>
+              <a:t>NFT 이미지 포함</a:t>
             </a:r>
             <a:endParaRPr lang="en-US" sz="1100" dirty="0"/>
           </a:p>
@@ -8313,7 +8255,7 @@
                 <a:ea typeface="Calibri" pitchFamily="34" charset="-122"/>
                 <a:cs typeface="Calibri" pitchFamily="34" charset="-120"/>
               </a:rPr>
-              <a:t>지갑 없이도 조회 가능</a:t>
+              <a:t>읽기 전용 조회</a:t>
             </a:r>
             <a:endParaRPr lang="en-US" sz="1100" dirty="0"/>
           </a:p>
@@ -8425,14 +8367,53 @@
       </p:sp>
       <p:sp>
         <p:nvSpPr>
-          <p:cNvPr id="4" name="Shape 2"/>
-          <p:cNvSpPr/>
-          <p:nvPr/>
-        </p:nvSpPr>
-        <p:spPr>
-          <a:xfrm>
-            <a:off x="274320" y="1005840"/>
-            <a:ext cx="2743200" cy="1645920"/>
+          <p:cNvPr id="4" name="Text 2"/>
+          <p:cNvSpPr/>
+          <p:nvPr/>
+        </p:nvSpPr>
+        <p:spPr>
+          <a:xfrm>
+            <a:off x="365760" y="960120"/>
+            <a:ext cx="8229600" cy="320040"/>
+          </a:xfrm>
+          <a:prstGeom prst="rect">
+            <a:avLst/>
+          </a:prstGeom>
+          <a:noFill/>
+          <a:ln/>
+        </p:spPr>
+        <p:txBody>
+          <a:bodyPr wrap="square" lIns="0" tIns="0" rIns="0" bIns="0" rtlCol="0" anchor="ctr"/>
+          <a:lstStyle/>
+          <a:p>
+            <a:pPr marL="0" indent="0">
+              <a:buNone/>
+            </a:pPr>
+            <a:r>
+              <a:rPr lang="en-US" sz="1300" b="1" dirty="0">
+                <a:solidFill>
+                  <a:srgbClr val="1C7293"/>
+                </a:solidFill>
+                <a:latin typeface="Arial Black" pitchFamily="34" charset="0"/>
+                <a:ea typeface="Arial Black" pitchFamily="34" charset="-122"/>
+                <a:cs typeface="Arial Black" pitchFamily="34" charset="-120"/>
+              </a:rPr>
+              <a:t>▶ 정상 낙찰 흐름</a:t>
+            </a:r>
+            <a:endParaRPr lang="en-US" sz="1300" dirty="0"/>
+          </a:p>
+        </p:txBody>
+      </p:sp>
+      <p:sp>
+        <p:nvSpPr>
+          <p:cNvPr id="5" name="Shape 3"/>
+          <p:cNvSpPr/>
+          <p:nvPr/>
+        </p:nvSpPr>
+        <p:spPr>
+          <a:xfrm>
+            <a:off x="274320" y="1325880"/>
+            <a:ext cx="2011680" cy="1371600"/>
           </a:xfrm>
           <a:prstGeom prst="rect">
             <a:avLst/>
@@ -8464,14 +8445,14 @@
       </p:sp>
       <p:sp>
         <p:nvSpPr>
-          <p:cNvPr id="5" name="Shape 3"/>
-          <p:cNvSpPr/>
-          <p:nvPr/>
-        </p:nvSpPr>
-        <p:spPr>
-          <a:xfrm>
-            <a:off x="274320" y="1005840"/>
-            <a:ext cx="2743200" cy="438912"/>
+          <p:cNvPr id="6" name="Shape 4"/>
+          <p:cNvSpPr/>
+          <p:nvPr/>
+        </p:nvSpPr>
+        <p:spPr>
+          <a:xfrm>
+            <a:off x="274320" y="1325880"/>
+            <a:ext cx="2011680" cy="384048"/>
           </a:xfrm>
           <a:prstGeom prst="rect">
             <a:avLst/>
@@ -8496,14 +8477,14 @@
       </p:sp>
       <p:sp>
         <p:nvSpPr>
-          <p:cNvPr id="6" name="Text 4"/>
-          <p:cNvSpPr/>
-          <p:nvPr/>
-        </p:nvSpPr>
-        <p:spPr>
-          <a:xfrm>
-            <a:off x="365760" y="1051560"/>
-            <a:ext cx="1828800" cy="365760"/>
+          <p:cNvPr id="7" name="Text 5"/>
+          <p:cNvSpPr/>
+          <p:nvPr/>
+        </p:nvSpPr>
+        <p:spPr>
+          <a:xfrm>
+            <a:off x="365760" y="1353312"/>
+            <a:ext cx="1828800" cy="347472"/>
           </a:xfrm>
           <a:prstGeom prst="rect">
             <a:avLst/>
@@ -8519,7 +8500,7 @@
               <a:buNone/>
             </a:pPr>
             <a:r>
-              <a:rPr lang="en-US" sz="1400" b="1" dirty="0">
+              <a:rPr lang="en-US" sz="1300" b="1" dirty="0">
                 <a:solidFill>
                   <a:srgbClr val="FFFFFF"/>
                 </a:solidFill>
@@ -8527,77 +8508,55 @@
                 <a:ea typeface="Arial Black" pitchFamily="34" charset="-122"/>
                 <a:cs typeface="Arial Black" pitchFamily="34" charset="-120"/>
               </a:rPr>
-              <a:t>01  NFT 발행</a:t>
-            </a:r>
-            <a:endParaRPr lang="en-US" sz="1400" dirty="0"/>
-          </a:p>
-        </p:txBody>
-      </p:sp>
-      <p:sp>
-        <p:nvSpPr>
-          <p:cNvPr id="7" name="Text 5"/>
-          <p:cNvSpPr/>
-          <p:nvPr/>
-        </p:nvSpPr>
-        <p:spPr>
-          <a:xfrm>
-            <a:off x="2194560" y="1051560"/>
-            <a:ext cx="731520" cy="365760"/>
-          </a:xfrm>
-          <a:prstGeom prst="rect">
-            <a:avLst/>
-          </a:prstGeom>
-          <a:noFill/>
-          <a:ln/>
-        </p:spPr>
-        <p:txBody>
-          <a:bodyPr wrap="square" lIns="0" tIns="0" rIns="0" bIns="0" rtlCol="0" anchor="ctr"/>
-          <a:lstStyle/>
-          <a:p>
-            <a:pPr marL="0" indent="0" algn="r">
-              <a:buNone/>
-            </a:pPr>
-            <a:r>
-              <a:rPr lang="en-US" sz="1000" dirty="0">
-                <a:solidFill>
-                  <a:srgbClr val="FFFFFF"/>
+              <a:t>01 NFT 발행</a:t>
+            </a:r>
+            <a:endParaRPr lang="en-US" sz="1300" dirty="0"/>
+          </a:p>
+        </p:txBody>
+      </p:sp>
+      <p:sp>
+        <p:nvSpPr>
+          <p:cNvPr id="8" name="Text 6"/>
+          <p:cNvSpPr/>
+          <p:nvPr/>
+        </p:nvSpPr>
+        <p:spPr>
+          <a:xfrm>
+            <a:off x="365760" y="1783080"/>
+            <a:ext cx="1828800" cy="777240"/>
+          </a:xfrm>
+          <a:prstGeom prst="rect">
+            <a:avLst/>
+          </a:prstGeom>
+          <a:noFill/>
+          <a:ln/>
+        </p:spPr>
+        <p:txBody>
+          <a:bodyPr wrap="square" lIns="0" tIns="0" rIns="0" bIns="0" rtlCol="0" anchor="ctr"/>
+          <a:lstStyle/>
+          <a:p>
+            <a:pPr marL="0" indent="0">
+              <a:buNone/>
+            </a:pPr>
+            <a:r>
+              <a:rPr lang="en-US" sz="1100" dirty="0">
+                <a:solidFill>
+                  <a:srgbClr val="4A6274"/>
                 </a:solidFill>
                 <a:latin typeface="Calibri" pitchFamily="34" charset="0"/>
                 <a:ea typeface="Calibri" pitchFamily="34" charset="-122"/>
                 <a:cs typeface="Calibri" pitchFamily="34" charset="-120"/>
               </a:rPr>
-              <a:t>판매자</a:t>
-            </a:r>
-            <a:endParaRPr lang="en-US" sz="1000" dirty="0"/>
-          </a:p>
-        </p:txBody>
-      </p:sp>
-      <p:sp>
-        <p:nvSpPr>
-          <p:cNvPr id="8" name="Text 6"/>
-          <p:cNvSpPr/>
-          <p:nvPr/>
-        </p:nvSpPr>
-        <p:spPr>
-          <a:xfrm>
-            <a:off x="365760" y="1554480"/>
-            <a:ext cx="2560320" cy="914400"/>
-          </a:xfrm>
-          <a:prstGeom prst="rect">
-            <a:avLst/>
-          </a:prstGeom>
-          <a:noFill/>
-          <a:ln/>
-        </p:spPr>
-        <p:txBody>
-          <a:bodyPr wrap="square" lIns="0" tIns="0" rIns="0" bIns="0" rtlCol="0" anchor="ctr"/>
-          <a:lstStyle/>
+              <a:t>이미지 업로드</a:t>
+            </a:r>
+            <a:endParaRPr lang="en-US" sz="1100" dirty="0"/>
+          </a:p>
           <a:p>
             <a:pPr marL="0" indent="0">
               <a:buNone/>
             </a:pPr>
             <a:r>
-              <a:rPr lang="en-US" sz="1150" dirty="0">
+              <a:rPr lang="en-US" sz="1100" dirty="0">
                 <a:solidFill>
                   <a:srgbClr val="4A6274"/>
                 </a:solidFill>
@@ -8605,9 +8564,9 @@
                 <a:ea typeface="Calibri" pitchFamily="34" charset="-122"/>
                 <a:cs typeface="Calibri" pitchFamily="34" charset="-120"/>
               </a:rPr>
-              <a:t>mint(to, uri)  →  Token ID 획득</a:t>
-            </a:r>
-            <a:endParaRPr lang="en-US" sz="1150" dirty="0"/>
+              <a:t>→ mint() 호출</a:t>
+            </a:r>
+            <a:endParaRPr lang="en-US" sz="1100" dirty="0"/>
           </a:p>
         </p:txBody>
       </p:sp>
@@ -8619,8 +8578,8 @@
         </p:nvSpPr>
         <p:spPr>
           <a:xfrm>
-            <a:off x="3017520" y="1828800"/>
-            <a:ext cx="228600" cy="0"/>
+            <a:off x="2286000" y="2011680"/>
+            <a:ext cx="182880" cy="0"/>
           </a:xfrm>
           <a:prstGeom prst="line">
             <a:avLst/>
@@ -8649,8 +8608,8 @@
         </p:nvSpPr>
         <p:spPr>
           <a:xfrm>
-            <a:off x="3246120" y="1005840"/>
-            <a:ext cx="2743200" cy="1645920"/>
+            <a:off x="2468880" y="1325880"/>
+            <a:ext cx="2011680" cy="1371600"/>
           </a:xfrm>
           <a:prstGeom prst="rect">
             <a:avLst/>
@@ -8688,8 +8647,8 @@
         </p:nvSpPr>
         <p:spPr>
           <a:xfrm>
-            <a:off x="3246120" y="1005840"/>
-            <a:ext cx="2743200" cy="438912"/>
+            <a:off x="2468880" y="1325880"/>
+            <a:ext cx="2011680" cy="384048"/>
           </a:xfrm>
           <a:prstGeom prst="rect">
             <a:avLst/>
@@ -8720,8 +8679,8 @@
         </p:nvSpPr>
         <p:spPr>
           <a:xfrm>
-            <a:off x="3337560" y="1051560"/>
-            <a:ext cx="1828800" cy="365760"/>
+            <a:off x="2560320" y="1353312"/>
+            <a:ext cx="1828800" cy="347472"/>
           </a:xfrm>
           <a:prstGeom prst="rect">
             <a:avLst/>
@@ -8737,7 +8696,7 @@
               <a:buNone/>
             </a:pPr>
             <a:r>
-              <a:rPr lang="en-US" sz="1400" b="1" dirty="0">
+              <a:rPr lang="en-US" sz="1300" b="1" dirty="0">
                 <a:solidFill>
                   <a:srgbClr val="FFFFFF"/>
                 </a:solidFill>
@@ -8745,9 +8704,9 @@
                 <a:ea typeface="Arial Black" pitchFamily="34" charset="-122"/>
                 <a:cs typeface="Arial Black" pitchFamily="34" charset="-120"/>
               </a:rPr>
-              <a:t>02  NFT 승인</a:t>
-            </a:r>
-            <a:endParaRPr lang="en-US" sz="1400" dirty="0"/>
+              <a:t>02 경매 등록</a:t>
+            </a:r>
+            <a:endParaRPr lang="en-US" sz="1300" dirty="0"/>
           </a:p>
         </p:txBody>
       </p:sp>
@@ -8759,63 +8718,41 @@
         </p:nvSpPr>
         <p:spPr>
           <a:xfrm>
-            <a:off x="5166360" y="1051560"/>
-            <a:ext cx="731520" cy="365760"/>
-          </a:xfrm>
-          <a:prstGeom prst="rect">
-            <a:avLst/>
-          </a:prstGeom>
-          <a:noFill/>
-          <a:ln/>
-        </p:spPr>
-        <p:txBody>
-          <a:bodyPr wrap="square" lIns="0" tIns="0" rIns="0" bIns="0" rtlCol="0" anchor="ctr"/>
-          <a:lstStyle/>
-          <a:p>
-            <a:pPr marL="0" indent="0" algn="r">
-              <a:buNone/>
-            </a:pPr>
-            <a:r>
-              <a:rPr lang="en-US" sz="1000" dirty="0">
-                <a:solidFill>
-                  <a:srgbClr val="FFFFFF"/>
+            <a:off x="2560320" y="1783080"/>
+            <a:ext cx="1828800" cy="777240"/>
+          </a:xfrm>
+          <a:prstGeom prst="rect">
+            <a:avLst/>
+          </a:prstGeom>
+          <a:noFill/>
+          <a:ln/>
+        </p:spPr>
+        <p:txBody>
+          <a:bodyPr wrap="square" lIns="0" tIns="0" rIns="0" bIns="0" rtlCol="0" anchor="ctr"/>
+          <a:lstStyle/>
+          <a:p>
+            <a:pPr marL="0" indent="0">
+              <a:buNone/>
+            </a:pPr>
+            <a:r>
+              <a:rPr lang="en-US" sz="1100" dirty="0">
+                <a:solidFill>
+                  <a:srgbClr val="4A6274"/>
                 </a:solidFill>
                 <a:latin typeface="Calibri" pitchFamily="34" charset="0"/>
                 <a:ea typeface="Calibri" pitchFamily="34" charset="-122"/>
                 <a:cs typeface="Calibri" pitchFamily="34" charset="-120"/>
               </a:rPr>
-              <a:t>판매자</a:t>
-            </a:r>
-            <a:endParaRPr lang="en-US" sz="1000" dirty="0"/>
-          </a:p>
-        </p:txBody>
-      </p:sp>
-      <p:sp>
-        <p:nvSpPr>
-          <p:cNvPr id="14" name="Text 12"/>
-          <p:cNvSpPr/>
-          <p:nvPr/>
-        </p:nvSpPr>
-        <p:spPr>
-          <a:xfrm>
-            <a:off x="3337560" y="1554480"/>
-            <a:ext cx="2560320" cy="914400"/>
-          </a:xfrm>
-          <a:prstGeom prst="rect">
-            <a:avLst/>
-          </a:prstGeom>
-          <a:noFill/>
-          <a:ln/>
-        </p:spPr>
-        <p:txBody>
-          <a:bodyPr wrap="square" lIns="0" tIns="0" rIns="0" bIns="0" rtlCol="0" anchor="ctr"/>
-          <a:lstStyle/>
+              <a:t>approve</a:t>
+            </a:r>
+            <a:endParaRPr lang="en-US" sz="1100" dirty="0"/>
+          </a:p>
           <a:p>
             <a:pPr marL="0" indent="0">
               <a:buNone/>
             </a:pPr>
             <a:r>
-              <a:rPr lang="en-US" sz="1150" dirty="0">
+              <a:rPr lang="en-US" sz="1100" dirty="0">
                 <a:solidFill>
                   <a:srgbClr val="4A6274"/>
                 </a:solidFill>
@@ -8823,22 +8760,22 @@
                 <a:ea typeface="Calibri" pitchFamily="34" charset="-122"/>
                 <a:cs typeface="Calibri" pitchFamily="34" charset="-120"/>
               </a:rPr>
-              <a:t>approve(AuctionAddr, tokenId)</a:t>
-            </a:r>
-            <a:endParaRPr lang="en-US" sz="1150" dirty="0"/>
-          </a:p>
-        </p:txBody>
-      </p:sp>
-      <p:sp>
-        <p:nvSpPr>
-          <p:cNvPr id="15" name="Shape 13"/>
-          <p:cNvSpPr/>
-          <p:nvPr/>
-        </p:nvSpPr>
-        <p:spPr>
-          <a:xfrm>
-            <a:off x="5989320" y="1828800"/>
-            <a:ext cx="228600" cy="0"/>
+              <a:t>→ createAuction()</a:t>
+            </a:r>
+            <a:endParaRPr lang="en-US" sz="1100" dirty="0"/>
+          </a:p>
+        </p:txBody>
+      </p:sp>
+      <p:sp>
+        <p:nvSpPr>
+          <p:cNvPr id="14" name="Shape 12"/>
+          <p:cNvSpPr/>
+          <p:nvPr/>
+        </p:nvSpPr>
+        <p:spPr>
+          <a:xfrm>
+            <a:off x="4480560" y="2011680"/>
+            <a:ext cx="182880" cy="0"/>
           </a:xfrm>
           <a:prstGeom prst="line">
             <a:avLst/>
@@ -8861,14 +8798,14 @@
       </p:sp>
       <p:sp>
         <p:nvSpPr>
-          <p:cNvPr id="16" name="Shape 14"/>
-          <p:cNvSpPr/>
-          <p:nvPr/>
-        </p:nvSpPr>
-        <p:spPr>
-          <a:xfrm>
-            <a:off x="6217920" y="1005840"/>
-            <a:ext cx="2743200" cy="1645920"/>
+          <p:cNvPr id="15" name="Shape 13"/>
+          <p:cNvSpPr/>
+          <p:nvPr/>
+        </p:nvSpPr>
+        <p:spPr>
+          <a:xfrm>
+            <a:off x="4663440" y="1325880"/>
+            <a:ext cx="2011680" cy="1371600"/>
           </a:xfrm>
           <a:prstGeom prst="rect">
             <a:avLst/>
@@ -8900,24 +8837,24 @@
       </p:sp>
       <p:sp>
         <p:nvSpPr>
-          <p:cNvPr id="17" name="Shape 15"/>
-          <p:cNvSpPr/>
-          <p:nvPr/>
-        </p:nvSpPr>
-        <p:spPr>
-          <a:xfrm>
-            <a:off x="6217920" y="1005840"/>
-            <a:ext cx="2743200" cy="438912"/>
+          <p:cNvPr id="16" name="Shape 14"/>
+          <p:cNvSpPr/>
+          <p:nvPr/>
+        </p:nvSpPr>
+        <p:spPr>
+          <a:xfrm>
+            <a:off x="4663440" y="1325880"/>
+            <a:ext cx="2011680" cy="384048"/>
           </a:xfrm>
           <a:prstGeom prst="rect">
             <a:avLst/>
           </a:prstGeom>
           <a:solidFill>
-            <a:srgbClr val="1C7293"/>
+            <a:srgbClr val="02C39A"/>
           </a:solidFill>
           <a:ln w="12700">
             <a:solidFill>
-              <a:srgbClr val="1C7293"/>
+              <a:srgbClr val="02C39A"/>
             </a:solidFill>
             <a:prstDash val="solid"/>
           </a:ln>
@@ -8932,14 +8869,14 @@
       </p:sp>
       <p:sp>
         <p:nvSpPr>
-          <p:cNvPr id="18" name="Text 16"/>
-          <p:cNvSpPr/>
-          <p:nvPr/>
-        </p:nvSpPr>
-        <p:spPr>
-          <a:xfrm>
-            <a:off x="6309360" y="1051560"/>
-            <a:ext cx="1828800" cy="365760"/>
+          <p:cNvPr id="17" name="Text 15"/>
+          <p:cNvSpPr/>
+          <p:nvPr/>
+        </p:nvSpPr>
+        <p:spPr>
+          <a:xfrm>
+            <a:off x="4754880" y="1353312"/>
+            <a:ext cx="1828800" cy="347472"/>
           </a:xfrm>
           <a:prstGeom prst="rect">
             <a:avLst/>
@@ -8955,7 +8892,7 @@
               <a:buNone/>
             </a:pPr>
             <a:r>
-              <a:rPr lang="en-US" sz="1400" b="1" dirty="0">
+              <a:rPr lang="en-US" sz="1300" b="1" dirty="0">
                 <a:solidFill>
                   <a:srgbClr val="FFFFFF"/>
                 </a:solidFill>
@@ -8963,77 +8900,55 @@
                 <a:ea typeface="Arial Black" pitchFamily="34" charset="-122"/>
                 <a:cs typeface="Arial Black" pitchFamily="34" charset="-120"/>
               </a:rPr>
-              <a:t>03  경매 등록</a:t>
-            </a:r>
-            <a:endParaRPr lang="en-US" sz="1400" dirty="0"/>
-          </a:p>
-        </p:txBody>
-      </p:sp>
-      <p:sp>
-        <p:nvSpPr>
-          <p:cNvPr id="19" name="Text 17"/>
-          <p:cNvSpPr/>
-          <p:nvPr/>
-        </p:nvSpPr>
-        <p:spPr>
-          <a:xfrm>
-            <a:off x="8138160" y="1051560"/>
-            <a:ext cx="731520" cy="365760"/>
-          </a:xfrm>
-          <a:prstGeom prst="rect">
-            <a:avLst/>
-          </a:prstGeom>
-          <a:noFill/>
-          <a:ln/>
-        </p:spPr>
-        <p:txBody>
-          <a:bodyPr wrap="square" lIns="0" tIns="0" rIns="0" bIns="0" rtlCol="0" anchor="ctr"/>
-          <a:lstStyle/>
-          <a:p>
-            <a:pPr marL="0" indent="0" algn="r">
-              <a:buNone/>
-            </a:pPr>
-            <a:r>
-              <a:rPr lang="en-US" sz="1000" dirty="0">
-                <a:solidFill>
-                  <a:srgbClr val="FFFFFF"/>
+              <a:t>03 입찰</a:t>
+            </a:r>
+            <a:endParaRPr lang="en-US" sz="1300" dirty="0"/>
+          </a:p>
+        </p:txBody>
+      </p:sp>
+      <p:sp>
+        <p:nvSpPr>
+          <p:cNvPr id="18" name="Text 16"/>
+          <p:cNvSpPr/>
+          <p:nvPr/>
+        </p:nvSpPr>
+        <p:spPr>
+          <a:xfrm>
+            <a:off x="4754880" y="1783080"/>
+            <a:ext cx="1828800" cy="777240"/>
+          </a:xfrm>
+          <a:prstGeom prst="rect">
+            <a:avLst/>
+          </a:prstGeom>
+          <a:noFill/>
+          <a:ln/>
+        </p:spPr>
+        <p:txBody>
+          <a:bodyPr wrap="square" lIns="0" tIns="0" rIns="0" bIns="0" rtlCol="0" anchor="ctr"/>
+          <a:lstStyle/>
+          <a:p>
+            <a:pPr marL="0" indent="0">
+              <a:buNone/>
+            </a:pPr>
+            <a:r>
+              <a:rPr lang="en-US" sz="1100" dirty="0">
+                <a:solidFill>
+                  <a:srgbClr val="4A6274"/>
                 </a:solidFill>
                 <a:latin typeface="Calibri" pitchFamily="34" charset="0"/>
                 <a:ea typeface="Calibri" pitchFamily="34" charset="-122"/>
                 <a:cs typeface="Calibri" pitchFamily="34" charset="-120"/>
               </a:rPr>
-              <a:t>판매자</a:t>
-            </a:r>
-            <a:endParaRPr lang="en-US" sz="1000" dirty="0"/>
-          </a:p>
-        </p:txBody>
-      </p:sp>
-      <p:sp>
-        <p:nvSpPr>
-          <p:cNvPr id="20" name="Text 18"/>
-          <p:cNvSpPr/>
-          <p:nvPr/>
-        </p:nvSpPr>
-        <p:spPr>
-          <a:xfrm>
-            <a:off x="6309360" y="1554480"/>
-            <a:ext cx="2560320" cy="914400"/>
-          </a:xfrm>
-          <a:prstGeom prst="rect">
-            <a:avLst/>
-          </a:prstGeom>
-          <a:noFill/>
-          <a:ln/>
-        </p:spPr>
-        <p:txBody>
-          <a:bodyPr wrap="square" lIns="0" tIns="0" rIns="0" bIns="0" rtlCol="0" anchor="ctr"/>
-          <a:lstStyle/>
+              <a:t>bid()</a:t>
+            </a:r>
+            <a:endParaRPr lang="en-US" sz="1100" dirty="0"/>
+          </a:p>
           <a:p>
             <a:pPr marL="0" indent="0">
               <a:buNone/>
             </a:pPr>
             <a:r>
-              <a:rPr lang="en-US" sz="1150" dirty="0">
+              <a:rPr lang="en-US" sz="1100" dirty="0">
                 <a:solidFill>
                   <a:srgbClr val="4A6274"/>
                 </a:solidFill>
@@ -9041,22 +8956,52 @@
                 <a:ea typeface="Calibri" pitchFamily="34" charset="-122"/>
                 <a:cs typeface="Calibri" pitchFamily="34" charset="-120"/>
               </a:rPr>
-              <a:t>createAuction(tokenId, price, dur)  →  Auction ID</a:t>
-            </a:r>
-            <a:endParaRPr lang="en-US" sz="1150" dirty="0"/>
-          </a:p>
-        </p:txBody>
-      </p:sp>
-      <p:sp>
-        <p:nvSpPr>
-          <p:cNvPr id="21" name="Shape 19"/>
-          <p:cNvSpPr/>
-          <p:nvPr/>
-        </p:nvSpPr>
-        <p:spPr>
-          <a:xfrm>
-            <a:off x="274320" y="2926080"/>
-            <a:ext cx="2743200" cy="1645920"/>
+              <a:t>+ ETH 전송</a:t>
+            </a:r>
+            <a:endParaRPr lang="en-US" sz="1100" dirty="0"/>
+          </a:p>
+        </p:txBody>
+      </p:sp>
+      <p:sp>
+        <p:nvSpPr>
+          <p:cNvPr id="19" name="Shape 17"/>
+          <p:cNvSpPr/>
+          <p:nvPr/>
+        </p:nvSpPr>
+        <p:spPr>
+          <a:xfrm>
+            <a:off x="6675120" y="2011680"/>
+            <a:ext cx="182880" cy="0"/>
+          </a:xfrm>
+          <a:prstGeom prst="line">
+            <a:avLst/>
+          </a:prstGeom>
+          <a:noFill/>
+          <a:ln w="25400">
+            <a:solidFill>
+              <a:srgbClr val="02C39A"/>
+            </a:solidFill>
+            <a:prstDash val="solid"/>
+          </a:ln>
+        </p:spPr>
+        <p:txBody>
+          <a:bodyPr/>
+          <a:lstStyle/>
+          <a:p>
+            <a:endParaRPr lang="ko-KR" altLang="en-US"/>
+          </a:p>
+        </p:txBody>
+      </p:sp>
+      <p:sp>
+        <p:nvSpPr>
+          <p:cNvPr id="20" name="Shape 18"/>
+          <p:cNvSpPr/>
+          <p:nvPr/>
+        </p:nvSpPr>
+        <p:spPr>
+          <a:xfrm>
+            <a:off x="6858000" y="1325880"/>
+            <a:ext cx="2011680" cy="1371600"/>
           </a:xfrm>
           <a:prstGeom prst="rect">
             <a:avLst/>
@@ -9088,24 +9033,24 @@
       </p:sp>
       <p:sp>
         <p:nvSpPr>
-          <p:cNvPr id="22" name="Shape 20"/>
-          <p:cNvSpPr/>
-          <p:nvPr/>
-        </p:nvSpPr>
-        <p:spPr>
-          <a:xfrm>
-            <a:off x="274320" y="2926080"/>
-            <a:ext cx="2743200" cy="438912"/>
+          <p:cNvPr id="21" name="Shape 19"/>
+          <p:cNvSpPr/>
+          <p:nvPr/>
+        </p:nvSpPr>
+        <p:spPr>
+          <a:xfrm>
+            <a:off x="6858000" y="1325880"/>
+            <a:ext cx="2011680" cy="384048"/>
           </a:xfrm>
           <a:prstGeom prst="rect">
             <a:avLst/>
           </a:prstGeom>
           <a:solidFill>
-            <a:srgbClr val="02C39A"/>
+            <a:srgbClr val="065A82"/>
           </a:solidFill>
           <a:ln w="12700">
             <a:solidFill>
-              <a:srgbClr val="02C39A"/>
+              <a:srgbClr val="065A82"/>
             </a:solidFill>
             <a:prstDash val="solid"/>
           </a:ln>
@@ -9120,14 +9065,14 @@
       </p:sp>
       <p:sp>
         <p:nvSpPr>
-          <p:cNvPr id="23" name="Text 21"/>
-          <p:cNvSpPr/>
-          <p:nvPr/>
-        </p:nvSpPr>
-        <p:spPr>
-          <a:xfrm>
-            <a:off x="365760" y="2971800"/>
-            <a:ext cx="1828800" cy="365760"/>
+          <p:cNvPr id="22" name="Text 20"/>
+          <p:cNvSpPr/>
+          <p:nvPr/>
+        </p:nvSpPr>
+        <p:spPr>
+          <a:xfrm>
+            <a:off x="6949440" y="1353312"/>
+            <a:ext cx="1828800" cy="347472"/>
           </a:xfrm>
           <a:prstGeom prst="rect">
             <a:avLst/>
@@ -9143,7 +9088,7 @@
               <a:buNone/>
             </a:pPr>
             <a:r>
-              <a:rPr lang="en-US" sz="1400" b="1" dirty="0">
+              <a:rPr lang="en-US" sz="1300" b="1" dirty="0">
                 <a:solidFill>
                   <a:srgbClr val="FFFFFF"/>
                 </a:solidFill>
@@ -9151,77 +9096,55 @@
                 <a:ea typeface="Arial Black" pitchFamily="34" charset="-122"/>
                 <a:cs typeface="Arial Black" pitchFamily="34" charset="-120"/>
               </a:rPr>
-              <a:t>04  입찰</a:t>
-            </a:r>
-            <a:endParaRPr lang="en-US" sz="1400" dirty="0"/>
-          </a:p>
-        </p:txBody>
-      </p:sp>
-      <p:sp>
-        <p:nvSpPr>
-          <p:cNvPr id="24" name="Text 22"/>
-          <p:cNvSpPr/>
-          <p:nvPr/>
-        </p:nvSpPr>
-        <p:spPr>
-          <a:xfrm>
-            <a:off x="2194560" y="2971800"/>
-            <a:ext cx="731520" cy="365760"/>
-          </a:xfrm>
-          <a:prstGeom prst="rect">
-            <a:avLst/>
-          </a:prstGeom>
-          <a:noFill/>
-          <a:ln/>
-        </p:spPr>
-        <p:txBody>
-          <a:bodyPr wrap="square" lIns="0" tIns="0" rIns="0" bIns="0" rtlCol="0" anchor="ctr"/>
-          <a:lstStyle/>
-          <a:p>
-            <a:pPr marL="0" indent="0" algn="r">
-              <a:buNone/>
-            </a:pPr>
-            <a:r>
-              <a:rPr lang="en-US" sz="1000" dirty="0">
-                <a:solidFill>
-                  <a:srgbClr val="FFFFFF"/>
+              <a:t>04 경매 종료</a:t>
+            </a:r>
+            <a:endParaRPr lang="en-US" sz="1300" dirty="0"/>
+          </a:p>
+        </p:txBody>
+      </p:sp>
+      <p:sp>
+        <p:nvSpPr>
+          <p:cNvPr id="23" name="Text 21"/>
+          <p:cNvSpPr/>
+          <p:nvPr/>
+        </p:nvSpPr>
+        <p:spPr>
+          <a:xfrm>
+            <a:off x="6949440" y="1783080"/>
+            <a:ext cx="1828800" cy="777240"/>
+          </a:xfrm>
+          <a:prstGeom prst="rect">
+            <a:avLst/>
+          </a:prstGeom>
+          <a:noFill/>
+          <a:ln/>
+        </p:spPr>
+        <p:txBody>
+          <a:bodyPr wrap="square" lIns="0" tIns="0" rIns="0" bIns="0" rtlCol="0" anchor="ctr"/>
+          <a:lstStyle/>
+          <a:p>
+            <a:pPr marL="0" indent="0">
+              <a:buNone/>
+            </a:pPr>
+            <a:r>
+              <a:rPr lang="en-US" sz="1100" dirty="0">
+                <a:solidFill>
+                  <a:srgbClr val="4A6274"/>
                 </a:solidFill>
                 <a:latin typeface="Calibri" pitchFamily="34" charset="0"/>
                 <a:ea typeface="Calibri" pitchFamily="34" charset="-122"/>
                 <a:cs typeface="Calibri" pitchFamily="34" charset="-120"/>
               </a:rPr>
-              <a:t>구매자</a:t>
-            </a:r>
-            <a:endParaRPr lang="en-US" sz="1000" dirty="0"/>
-          </a:p>
-        </p:txBody>
-      </p:sp>
-      <p:sp>
-        <p:nvSpPr>
-          <p:cNvPr id="25" name="Text 23"/>
-          <p:cNvSpPr/>
-          <p:nvPr/>
-        </p:nvSpPr>
-        <p:spPr>
-          <a:xfrm>
-            <a:off x="365760" y="3474720"/>
-            <a:ext cx="2560320" cy="914400"/>
-          </a:xfrm>
-          <a:prstGeom prst="rect">
-            <a:avLst/>
-          </a:prstGeom>
-          <a:noFill/>
-          <a:ln/>
-        </p:spPr>
-        <p:txBody>
-          <a:bodyPr wrap="square" lIns="0" tIns="0" rIns="0" bIns="0" rtlCol="0" anchor="ctr"/>
-          <a:lstStyle/>
+              <a:t>endAuction()</a:t>
+            </a:r>
+            <a:endParaRPr lang="en-US" sz="1100" dirty="0"/>
+          </a:p>
           <a:p>
             <a:pPr marL="0" indent="0">
               <a:buNone/>
             </a:pPr>
             <a:r>
-              <a:rPr lang="en-US" sz="1150" dirty="0">
+              <a:rPr lang="en-US" sz="1100" dirty="0">
                 <a:solidFill>
                   <a:srgbClr val="4A6274"/>
                 </a:solidFill>
@@ -9229,52 +9152,61 @@
                 <a:ea typeface="Calibri" pitchFamily="34" charset="-122"/>
                 <a:cs typeface="Calibri" pitchFamily="34" charset="-120"/>
               </a:rPr>
-              <a:t>bid(auctionId)  +  ETH 전송</a:t>
-            </a:r>
-            <a:endParaRPr lang="en-US" sz="1150" dirty="0"/>
-          </a:p>
-        </p:txBody>
-      </p:sp>
-      <p:sp>
-        <p:nvSpPr>
-          <p:cNvPr id="26" name="Shape 24"/>
-          <p:cNvSpPr/>
-          <p:nvPr/>
-        </p:nvSpPr>
-        <p:spPr>
-          <a:xfrm>
-            <a:off x="3017520" y="3749040"/>
-            <a:ext cx="228600" cy="0"/>
-          </a:xfrm>
-          <a:prstGeom prst="line">
-            <a:avLst/>
-          </a:prstGeom>
-          <a:noFill/>
-          <a:ln w="25400">
-            <a:solidFill>
-              <a:srgbClr val="02C39A"/>
-            </a:solidFill>
-            <a:prstDash val="solid"/>
-          </a:ln>
-        </p:spPr>
-        <p:txBody>
-          <a:bodyPr/>
-          <a:lstStyle/>
-          <a:p>
-            <a:endParaRPr lang="ko-KR" altLang="en-US"/>
-          </a:p>
-        </p:txBody>
-      </p:sp>
-      <p:sp>
-        <p:nvSpPr>
-          <p:cNvPr id="27" name="Shape 25"/>
-          <p:cNvSpPr/>
-          <p:nvPr/>
-        </p:nvSpPr>
-        <p:spPr>
-          <a:xfrm>
-            <a:off x="3246120" y="2926080"/>
-            <a:ext cx="2743200" cy="1645920"/>
+              <a:t>NFT·ETH 자동 이전</a:t>
+            </a:r>
+            <a:endParaRPr lang="en-US" sz="1100" dirty="0"/>
+          </a:p>
+        </p:txBody>
+      </p:sp>
+      <p:sp>
+        <p:nvSpPr>
+          <p:cNvPr id="24" name="Text 22"/>
+          <p:cNvSpPr/>
+          <p:nvPr/>
+        </p:nvSpPr>
+        <p:spPr>
+          <a:xfrm>
+            <a:off x="365760" y="2834640"/>
+            <a:ext cx="8229600" cy="320040"/>
+          </a:xfrm>
+          <a:prstGeom prst="rect">
+            <a:avLst/>
+          </a:prstGeom>
+          <a:noFill/>
+          <a:ln/>
+        </p:spPr>
+        <p:txBody>
+          <a:bodyPr wrap="square" lIns="0" tIns="0" rIns="0" bIns="0" rtlCol="0" anchor="ctr"/>
+          <a:lstStyle/>
+          <a:p>
+            <a:pPr marL="0" indent="0">
+              <a:buNone/>
+            </a:pPr>
+            <a:r>
+              <a:rPr lang="en-US" sz="1300" b="1" dirty="0">
+                <a:solidFill>
+                  <a:srgbClr val="E07B39"/>
+                </a:solidFill>
+                <a:latin typeface="Arial Black" pitchFamily="34" charset="0"/>
+                <a:ea typeface="Arial Black" pitchFamily="34" charset="-122"/>
+                <a:cs typeface="Arial Black" pitchFamily="34" charset="-120"/>
+              </a:rPr>
+              <a:t>▶ 판매자 취소 흐름 (신규)</a:t>
+            </a:r>
+            <a:endParaRPr lang="en-US" sz="1300" dirty="0"/>
+          </a:p>
+        </p:txBody>
+      </p:sp>
+      <p:sp>
+        <p:nvSpPr>
+          <p:cNvPr id="25" name="Shape 23"/>
+          <p:cNvSpPr/>
+          <p:nvPr/>
+        </p:nvSpPr>
+        <p:spPr>
+          <a:xfrm>
+            <a:off x="274320" y="3200400"/>
+            <a:ext cx="2011680" cy="1371600"/>
           </a:xfrm>
           <a:prstGeom prst="rect">
             <a:avLst/>
@@ -9306,24 +9238,24 @@
       </p:sp>
       <p:sp>
         <p:nvSpPr>
-          <p:cNvPr id="28" name="Shape 26"/>
-          <p:cNvSpPr/>
-          <p:nvPr/>
-        </p:nvSpPr>
-        <p:spPr>
-          <a:xfrm>
-            <a:off x="3246120" y="2926080"/>
-            <a:ext cx="2743200" cy="438912"/>
+          <p:cNvPr id="26" name="Shape 24"/>
+          <p:cNvSpPr/>
+          <p:nvPr/>
+        </p:nvSpPr>
+        <p:spPr>
+          <a:xfrm>
+            <a:off x="274320" y="3200400"/>
+            <a:ext cx="2011680" cy="384048"/>
           </a:xfrm>
           <a:prstGeom prst="rect">
             <a:avLst/>
           </a:prstGeom>
           <a:solidFill>
-            <a:srgbClr val="065A82"/>
+            <a:srgbClr val="1C7293"/>
           </a:solidFill>
           <a:ln w="12700">
             <a:solidFill>
-              <a:srgbClr val="065A82"/>
+              <a:srgbClr val="1C7293"/>
             </a:solidFill>
             <a:prstDash val="solid"/>
           </a:ln>
@@ -9338,14 +9270,14 @@
       </p:sp>
       <p:sp>
         <p:nvSpPr>
-          <p:cNvPr id="29" name="Text 27"/>
-          <p:cNvSpPr/>
-          <p:nvPr/>
-        </p:nvSpPr>
-        <p:spPr>
-          <a:xfrm>
-            <a:off x="3337560" y="2971800"/>
-            <a:ext cx="1828800" cy="365760"/>
+          <p:cNvPr id="27" name="Text 25"/>
+          <p:cNvSpPr/>
+          <p:nvPr/>
+        </p:nvSpPr>
+        <p:spPr>
+          <a:xfrm>
+            <a:off x="365760" y="3227832"/>
+            <a:ext cx="1828800" cy="347472"/>
           </a:xfrm>
           <a:prstGeom prst="rect">
             <a:avLst/>
@@ -9361,7 +9293,7 @@
               <a:buNone/>
             </a:pPr>
             <a:r>
-              <a:rPr lang="en-US" sz="1400" b="1" dirty="0">
+              <a:rPr lang="en-US" sz="1300" b="1" dirty="0">
                 <a:solidFill>
                   <a:srgbClr val="FFFFFF"/>
                 </a:solidFill>
@@ -9369,100 +9301,61 @@
                 <a:ea typeface="Arial Black" pitchFamily="34" charset="-122"/>
                 <a:cs typeface="Arial Black" pitchFamily="34" charset="-120"/>
               </a:rPr>
-              <a:t>05  경매 종료</a:t>
-            </a:r>
-            <a:endParaRPr lang="en-US" sz="1400" dirty="0"/>
-          </a:p>
-        </p:txBody>
-      </p:sp>
-      <p:sp>
-        <p:nvSpPr>
-          <p:cNvPr id="30" name="Text 28"/>
-          <p:cNvSpPr/>
-          <p:nvPr/>
-        </p:nvSpPr>
-        <p:spPr>
-          <a:xfrm>
-            <a:off x="5166360" y="2971800"/>
-            <a:ext cx="731520" cy="365760"/>
-          </a:xfrm>
-          <a:prstGeom prst="rect">
-            <a:avLst/>
-          </a:prstGeom>
-          <a:noFill/>
-          <a:ln/>
-        </p:spPr>
-        <p:txBody>
-          <a:bodyPr wrap="square" lIns="0" tIns="0" rIns="0" bIns="0" rtlCol="0" anchor="ctr"/>
-          <a:lstStyle/>
-          <a:p>
-            <a:pPr marL="0" indent="0" algn="r">
-              <a:buNone/>
-            </a:pPr>
-            <a:r>
-              <a:rPr lang="en-US" sz="1000" dirty="0">
-                <a:solidFill>
-                  <a:srgbClr val="FFFFFF"/>
+              <a:t>01 NFT 발행</a:t>
+            </a:r>
+            <a:endParaRPr lang="en-US" sz="1300" dirty="0"/>
+          </a:p>
+        </p:txBody>
+      </p:sp>
+      <p:sp>
+        <p:nvSpPr>
+          <p:cNvPr id="28" name="Text 26"/>
+          <p:cNvSpPr/>
+          <p:nvPr/>
+        </p:nvSpPr>
+        <p:spPr>
+          <a:xfrm>
+            <a:off x="365760" y="3657600"/>
+            <a:ext cx="1828800" cy="777240"/>
+          </a:xfrm>
+          <a:prstGeom prst="rect">
+            <a:avLst/>
+          </a:prstGeom>
+          <a:noFill/>
+          <a:ln/>
+        </p:spPr>
+        <p:txBody>
+          <a:bodyPr wrap="square" lIns="0" tIns="0" rIns="0" bIns="0" rtlCol="0" anchor="ctr"/>
+          <a:lstStyle/>
+          <a:p>
+            <a:pPr marL="0" indent="0">
+              <a:buNone/>
+            </a:pPr>
+            <a:r>
+              <a:rPr lang="en-US" sz="1100" dirty="0">
+                <a:solidFill>
+                  <a:srgbClr val="4A6274"/>
                 </a:solidFill>
                 <a:latin typeface="Calibri" pitchFamily="34" charset="0"/>
                 <a:ea typeface="Calibri" pitchFamily="34" charset="-122"/>
                 <a:cs typeface="Calibri" pitchFamily="34" charset="-120"/>
               </a:rPr>
-              <a:t>누구든</a:t>
-            </a:r>
-            <a:endParaRPr lang="en-US" sz="1000" dirty="0"/>
-          </a:p>
-        </p:txBody>
-      </p:sp>
-      <p:sp>
-        <p:nvSpPr>
-          <p:cNvPr id="31" name="Text 29"/>
-          <p:cNvSpPr/>
-          <p:nvPr/>
-        </p:nvSpPr>
-        <p:spPr>
-          <a:xfrm>
-            <a:off x="3337560" y="3474720"/>
-            <a:ext cx="2560320" cy="914400"/>
-          </a:xfrm>
-          <a:prstGeom prst="rect">
-            <a:avLst/>
-          </a:prstGeom>
-          <a:noFill/>
-          <a:ln/>
-        </p:spPr>
-        <p:txBody>
-          <a:bodyPr wrap="square" lIns="0" tIns="0" rIns="0" bIns="0" rtlCol="0" anchor="ctr"/>
-          <a:lstStyle/>
-          <a:p>
-            <a:pPr marL="0" indent="0">
-              <a:buNone/>
-            </a:pPr>
-            <a:r>
-              <a:rPr lang="en-US" sz="1150" dirty="0">
-                <a:solidFill>
-                  <a:srgbClr val="4A6274"/>
-                </a:solidFill>
-                <a:latin typeface="Calibri" pitchFamily="34" charset="0"/>
-                <a:ea typeface="Calibri" pitchFamily="34" charset="-122"/>
-                <a:cs typeface="Calibri" pitchFamily="34" charset="-120"/>
-              </a:rPr>
-              <a:t>endAuction()  →  NFT→낙찰자 / ETH→판매자</a:t>
-            </a:r>
-            <a:endParaRPr lang="en-US" sz="1150" dirty="0"/>
-          </a:p>
-        </p:txBody>
-      </p:sp>
-      <p:sp>
-        <p:nvSpPr>
-          <p:cNvPr id="32" name="Shape 30"/>
-          <p:cNvSpPr/>
-          <p:nvPr/>
-        </p:nvSpPr>
-        <p:spPr>
-          <a:xfrm>
-            <a:off x="5989320" y="3749040"/>
-            <a:ext cx="228600" cy="0"/>
+              <a:t>mint() 호출</a:t>
+            </a:r>
+            <a:endParaRPr lang="en-US" sz="1100" dirty="0"/>
+          </a:p>
+        </p:txBody>
+      </p:sp>
+      <p:sp>
+        <p:nvSpPr>
+          <p:cNvPr id="29" name="Shape 27"/>
+          <p:cNvSpPr/>
+          <p:nvPr/>
+        </p:nvSpPr>
+        <p:spPr>
+          <a:xfrm>
+            <a:off x="2286000" y="3886200"/>
+            <a:ext cx="182880" cy="0"/>
           </a:xfrm>
           <a:prstGeom prst="line">
             <a:avLst/>
@@ -9470,7 +9363,7 @@
           <a:noFill/>
           <a:ln w="25400">
             <a:solidFill>
-              <a:srgbClr val="02C39A"/>
+              <a:srgbClr val="E07B39"/>
             </a:solidFill>
             <a:prstDash val="solid"/>
           </a:ln>
@@ -9485,14 +9378,14 @@
       </p:sp>
       <p:sp>
         <p:nvSpPr>
-          <p:cNvPr id="33" name="Shape 31"/>
-          <p:cNvSpPr/>
-          <p:nvPr/>
-        </p:nvSpPr>
-        <p:spPr>
-          <a:xfrm>
-            <a:off x="6217920" y="2926080"/>
-            <a:ext cx="2743200" cy="1645920"/>
+          <p:cNvPr id="30" name="Shape 28"/>
+          <p:cNvSpPr/>
+          <p:nvPr/>
+        </p:nvSpPr>
+        <p:spPr>
+          <a:xfrm>
+            <a:off x="2468880" y="3200400"/>
+            <a:ext cx="2011680" cy="1371600"/>
           </a:xfrm>
           <a:prstGeom prst="rect">
             <a:avLst/>
@@ -9524,14 +9417,372 @@
       </p:sp>
       <p:sp>
         <p:nvSpPr>
+          <p:cNvPr id="31" name="Shape 29"/>
+          <p:cNvSpPr/>
+          <p:nvPr/>
+        </p:nvSpPr>
+        <p:spPr>
+          <a:xfrm>
+            <a:off x="2468880" y="3200400"/>
+            <a:ext cx="2011680" cy="384048"/>
+          </a:xfrm>
+          <a:prstGeom prst="rect">
+            <a:avLst/>
+          </a:prstGeom>
+          <a:solidFill>
+            <a:srgbClr val="1C7293"/>
+          </a:solidFill>
+          <a:ln w="12700">
+            <a:solidFill>
+              <a:srgbClr val="1C7293"/>
+            </a:solidFill>
+            <a:prstDash val="solid"/>
+          </a:ln>
+        </p:spPr>
+        <p:txBody>
+          <a:bodyPr/>
+          <a:lstStyle/>
+          <a:p>
+            <a:endParaRPr lang="ko-KR" altLang="en-US"/>
+          </a:p>
+        </p:txBody>
+      </p:sp>
+      <p:sp>
+        <p:nvSpPr>
+          <p:cNvPr id="32" name="Text 30"/>
+          <p:cNvSpPr/>
+          <p:nvPr/>
+        </p:nvSpPr>
+        <p:spPr>
+          <a:xfrm>
+            <a:off x="2560320" y="3227832"/>
+            <a:ext cx="1828800" cy="347472"/>
+          </a:xfrm>
+          <a:prstGeom prst="rect">
+            <a:avLst/>
+          </a:prstGeom>
+          <a:noFill/>
+          <a:ln/>
+        </p:spPr>
+        <p:txBody>
+          <a:bodyPr wrap="square" lIns="0" tIns="0" rIns="0" bIns="0" rtlCol="0" anchor="ctr"/>
+          <a:lstStyle/>
+          <a:p>
+            <a:pPr marL="0" indent="0">
+              <a:buNone/>
+            </a:pPr>
+            <a:r>
+              <a:rPr lang="en-US" sz="1300" b="1" dirty="0">
+                <a:solidFill>
+                  <a:srgbClr val="FFFFFF"/>
+                </a:solidFill>
+                <a:latin typeface="Arial Black" pitchFamily="34" charset="0"/>
+                <a:ea typeface="Arial Black" pitchFamily="34" charset="-122"/>
+                <a:cs typeface="Arial Black" pitchFamily="34" charset="-120"/>
+              </a:rPr>
+              <a:t>02 경매 등록</a:t>
+            </a:r>
+            <a:endParaRPr lang="en-US" sz="1300" dirty="0"/>
+          </a:p>
+        </p:txBody>
+      </p:sp>
+      <p:sp>
+        <p:nvSpPr>
+          <p:cNvPr id="33" name="Text 31"/>
+          <p:cNvSpPr/>
+          <p:nvPr/>
+        </p:nvSpPr>
+        <p:spPr>
+          <a:xfrm>
+            <a:off x="2560320" y="3657600"/>
+            <a:ext cx="1828800" cy="777240"/>
+          </a:xfrm>
+          <a:prstGeom prst="rect">
+            <a:avLst/>
+          </a:prstGeom>
+          <a:noFill/>
+          <a:ln/>
+        </p:spPr>
+        <p:txBody>
+          <a:bodyPr wrap="square" lIns="0" tIns="0" rIns="0" bIns="0" rtlCol="0" anchor="ctr"/>
+          <a:lstStyle/>
+          <a:p>
+            <a:pPr marL="0" indent="0">
+              <a:buNone/>
+            </a:pPr>
+            <a:r>
+              <a:rPr lang="en-US" sz="1100" dirty="0">
+                <a:solidFill>
+                  <a:srgbClr val="4A6274"/>
+                </a:solidFill>
+                <a:latin typeface="Calibri" pitchFamily="34" charset="0"/>
+                <a:ea typeface="Calibri" pitchFamily="34" charset="-122"/>
+                <a:cs typeface="Calibri" pitchFamily="34" charset="-120"/>
+              </a:rPr>
+              <a:t>createAuction()</a:t>
+            </a:r>
+            <a:endParaRPr lang="en-US" sz="1100" dirty="0"/>
+          </a:p>
+        </p:txBody>
+      </p:sp>
+      <p:sp>
+        <p:nvSpPr>
           <p:cNvPr id="34" name="Shape 32"/>
           <p:cNvSpPr/>
           <p:nvPr/>
         </p:nvSpPr>
         <p:spPr>
           <a:xfrm>
-            <a:off x="6217920" y="2926080"/>
-            <a:ext cx="2743200" cy="438912"/>
+            <a:off x="4480560" y="3886200"/>
+            <a:ext cx="182880" cy="0"/>
+          </a:xfrm>
+          <a:prstGeom prst="line">
+            <a:avLst/>
+          </a:prstGeom>
+          <a:noFill/>
+          <a:ln w="25400">
+            <a:solidFill>
+              <a:srgbClr val="E07B39"/>
+            </a:solidFill>
+            <a:prstDash val="solid"/>
+          </a:ln>
+        </p:spPr>
+        <p:txBody>
+          <a:bodyPr/>
+          <a:lstStyle/>
+          <a:p>
+            <a:endParaRPr lang="ko-KR" altLang="en-US"/>
+          </a:p>
+        </p:txBody>
+      </p:sp>
+      <p:sp>
+        <p:nvSpPr>
+          <p:cNvPr id="35" name="Shape 33"/>
+          <p:cNvSpPr/>
+          <p:nvPr/>
+        </p:nvSpPr>
+        <p:spPr>
+          <a:xfrm>
+            <a:off x="4663440" y="3200400"/>
+            <a:ext cx="2011680" cy="1371600"/>
+          </a:xfrm>
+          <a:prstGeom prst="rect">
+            <a:avLst/>
+          </a:prstGeom>
+          <a:solidFill>
+            <a:srgbClr val="FFFFFF"/>
+          </a:solidFill>
+          <a:ln w="12700">
+            <a:solidFill>
+              <a:srgbClr val="D0E8F5"/>
+            </a:solidFill>
+            <a:prstDash val="solid"/>
+          </a:ln>
+          <a:effectLst>
+            <a:outerShdw blurRad="76200" dist="25400" dir="8100000" algn="bl" rotWithShape="0">
+              <a:srgbClr val="000000">
+                <a:alpha val="13000"/>
+              </a:srgbClr>
+            </a:outerShdw>
+          </a:effectLst>
+        </p:spPr>
+        <p:txBody>
+          <a:bodyPr/>
+          <a:lstStyle/>
+          <a:p>
+            <a:endParaRPr lang="ko-KR" altLang="en-US"/>
+          </a:p>
+        </p:txBody>
+      </p:sp>
+      <p:sp>
+        <p:nvSpPr>
+          <p:cNvPr id="36" name="Shape 34"/>
+          <p:cNvSpPr/>
+          <p:nvPr/>
+        </p:nvSpPr>
+        <p:spPr>
+          <a:xfrm>
+            <a:off x="4663440" y="3200400"/>
+            <a:ext cx="2011680" cy="384048"/>
+          </a:xfrm>
+          <a:prstGeom prst="rect">
+            <a:avLst/>
+          </a:prstGeom>
+          <a:solidFill>
+            <a:srgbClr val="02C39A"/>
+          </a:solidFill>
+          <a:ln w="12700">
+            <a:solidFill>
+              <a:srgbClr val="02C39A"/>
+            </a:solidFill>
+            <a:prstDash val="solid"/>
+          </a:ln>
+        </p:spPr>
+        <p:txBody>
+          <a:bodyPr/>
+          <a:lstStyle/>
+          <a:p>
+            <a:endParaRPr lang="ko-KR" altLang="en-US"/>
+          </a:p>
+        </p:txBody>
+      </p:sp>
+      <p:sp>
+        <p:nvSpPr>
+          <p:cNvPr id="37" name="Text 35"/>
+          <p:cNvSpPr/>
+          <p:nvPr/>
+        </p:nvSpPr>
+        <p:spPr>
+          <a:xfrm>
+            <a:off x="4754880" y="3227832"/>
+            <a:ext cx="1828800" cy="347472"/>
+          </a:xfrm>
+          <a:prstGeom prst="rect">
+            <a:avLst/>
+          </a:prstGeom>
+          <a:noFill/>
+          <a:ln/>
+        </p:spPr>
+        <p:txBody>
+          <a:bodyPr wrap="square" lIns="0" tIns="0" rIns="0" bIns="0" rtlCol="0" anchor="ctr"/>
+          <a:lstStyle/>
+          <a:p>
+            <a:pPr marL="0" indent="0">
+              <a:buNone/>
+            </a:pPr>
+            <a:r>
+              <a:rPr lang="en-US" sz="1300" b="1" dirty="0">
+                <a:solidFill>
+                  <a:srgbClr val="FFFFFF"/>
+                </a:solidFill>
+                <a:latin typeface="Arial Black" pitchFamily="34" charset="0"/>
+                <a:ea typeface="Arial Black" pitchFamily="34" charset="-122"/>
+                <a:cs typeface="Arial Black" pitchFamily="34" charset="-120"/>
+              </a:rPr>
+              <a:t>03 입찰 (선택)</a:t>
+            </a:r>
+            <a:endParaRPr lang="en-US" sz="1300" dirty="0"/>
+          </a:p>
+        </p:txBody>
+      </p:sp>
+      <p:sp>
+        <p:nvSpPr>
+          <p:cNvPr id="38" name="Text 36"/>
+          <p:cNvSpPr/>
+          <p:nvPr/>
+        </p:nvSpPr>
+        <p:spPr>
+          <a:xfrm>
+            <a:off x="4754880" y="3657600"/>
+            <a:ext cx="1828800" cy="777240"/>
+          </a:xfrm>
+          <a:prstGeom prst="rect">
+            <a:avLst/>
+          </a:prstGeom>
+          <a:noFill/>
+          <a:ln/>
+        </p:spPr>
+        <p:txBody>
+          <a:bodyPr wrap="square" lIns="0" tIns="0" rIns="0" bIns="0" rtlCol="0" anchor="ctr"/>
+          <a:lstStyle/>
+          <a:p>
+            <a:pPr marL="0" indent="0">
+              <a:buNone/>
+            </a:pPr>
+            <a:r>
+              <a:rPr lang="en-US" sz="1100" dirty="0">
+                <a:solidFill>
+                  <a:srgbClr val="4A6274"/>
+                </a:solidFill>
+                <a:latin typeface="Calibri" pitchFamily="34" charset="0"/>
+                <a:ea typeface="Calibri" pitchFamily="34" charset="-122"/>
+                <a:cs typeface="Calibri" pitchFamily="34" charset="-120"/>
+              </a:rPr>
+              <a:t>구매자 bid()</a:t>
+            </a:r>
+            <a:endParaRPr lang="en-US" sz="1100" dirty="0"/>
+          </a:p>
+        </p:txBody>
+      </p:sp>
+      <p:sp>
+        <p:nvSpPr>
+          <p:cNvPr id="39" name="Shape 37"/>
+          <p:cNvSpPr/>
+          <p:nvPr/>
+        </p:nvSpPr>
+        <p:spPr>
+          <a:xfrm>
+            <a:off x="6675120" y="3886200"/>
+            <a:ext cx="182880" cy="0"/>
+          </a:xfrm>
+          <a:prstGeom prst="line">
+            <a:avLst/>
+          </a:prstGeom>
+          <a:noFill/>
+          <a:ln w="25400">
+            <a:solidFill>
+              <a:srgbClr val="E07B39"/>
+            </a:solidFill>
+            <a:prstDash val="solid"/>
+          </a:ln>
+        </p:spPr>
+        <p:txBody>
+          <a:bodyPr/>
+          <a:lstStyle/>
+          <a:p>
+            <a:endParaRPr lang="ko-KR" altLang="en-US"/>
+          </a:p>
+        </p:txBody>
+      </p:sp>
+      <p:sp>
+        <p:nvSpPr>
+          <p:cNvPr id="40" name="Shape 38"/>
+          <p:cNvSpPr/>
+          <p:nvPr/>
+        </p:nvSpPr>
+        <p:spPr>
+          <a:xfrm>
+            <a:off x="6858000" y="3200400"/>
+            <a:ext cx="2011680" cy="1371600"/>
+          </a:xfrm>
+          <a:prstGeom prst="rect">
+            <a:avLst/>
+          </a:prstGeom>
+          <a:solidFill>
+            <a:srgbClr val="FFFFFF"/>
+          </a:solidFill>
+          <a:ln w="12700">
+            <a:solidFill>
+              <a:srgbClr val="D0E8F5"/>
+            </a:solidFill>
+            <a:prstDash val="solid"/>
+          </a:ln>
+          <a:effectLst>
+            <a:outerShdw blurRad="76200" dist="25400" dir="8100000" algn="bl" rotWithShape="0">
+              <a:srgbClr val="000000">
+                <a:alpha val="13000"/>
+              </a:srgbClr>
+            </a:outerShdw>
+          </a:effectLst>
+        </p:spPr>
+        <p:txBody>
+          <a:bodyPr/>
+          <a:lstStyle/>
+          <a:p>
+            <a:endParaRPr lang="ko-KR" altLang="en-US"/>
+          </a:p>
+        </p:txBody>
+      </p:sp>
+      <p:sp>
+        <p:nvSpPr>
+          <p:cNvPr id="41" name="Shape 39"/>
+          <p:cNvSpPr/>
+          <p:nvPr/>
+        </p:nvSpPr>
+        <p:spPr>
+          <a:xfrm>
+            <a:off x="6858000" y="3200400"/>
+            <a:ext cx="2011680" cy="384048"/>
           </a:xfrm>
           <a:prstGeom prst="rect">
             <a:avLst/>
@@ -9556,14 +9807,14 @@
       </p:sp>
       <p:sp>
         <p:nvSpPr>
-          <p:cNvPr id="35" name="Text 33"/>
-          <p:cNvSpPr/>
-          <p:nvPr/>
-        </p:nvSpPr>
-        <p:spPr>
-          <a:xfrm>
-            <a:off x="6309360" y="2971800"/>
-            <a:ext cx="1828800" cy="365760"/>
+          <p:cNvPr id="42" name="Text 40"/>
+          <p:cNvSpPr/>
+          <p:nvPr/>
+        </p:nvSpPr>
+        <p:spPr>
+          <a:xfrm>
+            <a:off x="6949440" y="3227832"/>
+            <a:ext cx="1828800" cy="347472"/>
           </a:xfrm>
           <a:prstGeom prst="rect">
             <a:avLst/>
@@ -9579,7 +9830,7 @@
               <a:buNone/>
             </a:pPr>
             <a:r>
-              <a:rPr lang="en-US" sz="1400" b="1" dirty="0">
+              <a:rPr lang="en-US" sz="1300" b="1" dirty="0">
                 <a:solidFill>
                   <a:srgbClr val="FFFFFF"/>
                 </a:solidFill>
@@ -9587,77 +9838,55 @@
                 <a:ea typeface="Arial Black" pitchFamily="34" charset="-122"/>
                 <a:cs typeface="Arial Black" pitchFamily="34" charset="-120"/>
               </a:rPr>
-              <a:t>06  환불</a:t>
-            </a:r>
-            <a:endParaRPr lang="en-US" sz="1400" dirty="0"/>
-          </a:p>
-        </p:txBody>
-      </p:sp>
-      <p:sp>
-        <p:nvSpPr>
-          <p:cNvPr id="36" name="Text 34"/>
-          <p:cNvSpPr/>
-          <p:nvPr/>
-        </p:nvSpPr>
-        <p:spPr>
-          <a:xfrm>
-            <a:off x="8138160" y="2971800"/>
-            <a:ext cx="731520" cy="365760"/>
-          </a:xfrm>
-          <a:prstGeom prst="rect">
-            <a:avLst/>
-          </a:prstGeom>
-          <a:noFill/>
-          <a:ln/>
-        </p:spPr>
-        <p:txBody>
-          <a:bodyPr wrap="square" lIns="0" tIns="0" rIns="0" bIns="0" rtlCol="0" anchor="ctr"/>
-          <a:lstStyle/>
-          <a:p>
-            <a:pPr marL="0" indent="0" algn="r">
-              <a:buNone/>
-            </a:pPr>
-            <a:r>
-              <a:rPr lang="en-US" sz="1000" dirty="0">
-                <a:solidFill>
-                  <a:srgbClr val="FFFFFF"/>
+              <a:t>04 경매 취소</a:t>
+            </a:r>
+            <a:endParaRPr lang="en-US" sz="1300" dirty="0"/>
+          </a:p>
+        </p:txBody>
+      </p:sp>
+      <p:sp>
+        <p:nvSpPr>
+          <p:cNvPr id="43" name="Text 41"/>
+          <p:cNvSpPr/>
+          <p:nvPr/>
+        </p:nvSpPr>
+        <p:spPr>
+          <a:xfrm>
+            <a:off x="6949440" y="3657600"/>
+            <a:ext cx="1828800" cy="777240"/>
+          </a:xfrm>
+          <a:prstGeom prst="rect">
+            <a:avLst/>
+          </a:prstGeom>
+          <a:noFill/>
+          <a:ln/>
+        </p:spPr>
+        <p:txBody>
+          <a:bodyPr wrap="square" lIns="0" tIns="0" rIns="0" bIns="0" rtlCol="0" anchor="ctr"/>
+          <a:lstStyle/>
+          <a:p>
+            <a:pPr marL="0" indent="0">
+              <a:buNone/>
+            </a:pPr>
+            <a:r>
+              <a:rPr lang="en-US" sz="1100" dirty="0">
+                <a:solidFill>
+                  <a:srgbClr val="4A6274"/>
                 </a:solidFill>
                 <a:latin typeface="Calibri" pitchFamily="34" charset="0"/>
                 <a:ea typeface="Calibri" pitchFamily="34" charset="-122"/>
                 <a:cs typeface="Calibri" pitchFamily="34" charset="-120"/>
               </a:rPr>
-              <a:t>입찰자</a:t>
-            </a:r>
-            <a:endParaRPr lang="en-US" sz="1000" dirty="0"/>
-          </a:p>
-        </p:txBody>
-      </p:sp>
-      <p:sp>
-        <p:nvSpPr>
-          <p:cNvPr id="37" name="Text 35"/>
-          <p:cNvSpPr/>
-          <p:nvPr/>
-        </p:nvSpPr>
-        <p:spPr>
-          <a:xfrm>
-            <a:off x="6309360" y="3474720"/>
-            <a:ext cx="2560320" cy="914400"/>
-          </a:xfrm>
-          <a:prstGeom prst="rect">
-            <a:avLst/>
-          </a:prstGeom>
-          <a:noFill/>
-          <a:ln/>
-        </p:spPr>
-        <p:txBody>
-          <a:bodyPr wrap="square" lIns="0" tIns="0" rIns="0" bIns="0" rtlCol="0" anchor="ctr"/>
-          <a:lstStyle/>
+              <a:t>cancelAuction()</a:t>
+            </a:r>
+            <a:endParaRPr lang="en-US" sz="1100" dirty="0"/>
+          </a:p>
           <a:p>
             <a:pPr marL="0" indent="0">
               <a:buNone/>
             </a:pPr>
             <a:r>
-              <a:rPr lang="en-US" sz="1150" dirty="0">
+              <a:rPr lang="en-US" sz="1100" dirty="0">
                 <a:solidFill>
                   <a:srgbClr val="4A6274"/>
                 </a:solidFill>
@@ -9665,9 +9894,9 @@
                 <a:ea typeface="Calibri" pitchFamily="34" charset="-122"/>
                 <a:cs typeface="Calibri" pitchFamily="34" charset="-120"/>
               </a:rPr>
-              <a:t>withdraw()  →  패자 ETH 반환</a:t>
-            </a:r>
-            <a:endParaRPr lang="en-US" sz="1150" dirty="0"/>
+              <a:t>→ 입찰자 즉시 환불</a:t>
+            </a:r>
+            <a:endParaRPr lang="en-US" sz="1100" dirty="0"/>
           </a:p>
         </p:txBody>
       </p:sp>
@@ -9784,7 +10013,7 @@
         <p:spPr>
           <a:xfrm>
             <a:off x="274320" y="987552"/>
-            <a:ext cx="8595360" cy="685800"/>
+            <a:ext cx="8595360" cy="576072"/>
           </a:xfrm>
           <a:prstGeom prst="rect">
             <a:avLst/>
@@ -9823,7 +10052,7 @@
         <p:spPr>
           <a:xfrm>
             <a:off x="274320" y="987552"/>
-            <a:ext cx="411480" cy="685800"/>
+            <a:ext cx="365760" cy="576072"/>
           </a:xfrm>
           <a:prstGeom prst="rect">
             <a:avLst/>
@@ -9854,8 +10083,8 @@
         </p:nvSpPr>
         <p:spPr>
           <a:xfrm>
-            <a:off x="274320" y="1152144"/>
-            <a:ext cx="411480" cy="365760"/>
+            <a:off x="274320" y="1106424"/>
+            <a:ext cx="365760" cy="347472"/>
           </a:xfrm>
           <a:prstGeom prst="rect">
             <a:avLst/>
@@ -9871,7 +10100,7 @@
               <a:buNone/>
             </a:pPr>
             <a:r>
-              <a:rPr lang="en-US" sz="1600" b="1" dirty="0">
+              <a:rPr lang="en-US" sz="1400" b="1" dirty="0">
                 <a:solidFill>
                   <a:srgbClr val="FFFFFF"/>
                 </a:solidFill>
@@ -9881,7 +10110,7 @@
               </a:rPr>
               <a:t>1</a:t>
             </a:r>
-            <a:endParaRPr lang="en-US" sz="1600" dirty="0"/>
+            <a:endParaRPr lang="en-US" sz="1400" dirty="0"/>
           </a:p>
         </p:txBody>
       </p:sp>
@@ -9893,8 +10122,8 @@
         </p:nvSpPr>
         <p:spPr>
           <a:xfrm>
-            <a:off x="777240" y="1042416"/>
-            <a:ext cx="3200400" cy="320040"/>
+            <a:off x="749808" y="1024128"/>
+            <a:ext cx="3017520" cy="274320"/>
           </a:xfrm>
           <a:prstGeom prst="rect">
             <a:avLst/>
@@ -9910,7 +10139,7 @@
               <a:buNone/>
             </a:pPr>
             <a:r>
-              <a:rPr lang="en-US" sz="1300" b="1" dirty="0">
+              <a:rPr lang="en-US" sz="1200" b="1" dirty="0">
                 <a:solidFill>
                   <a:srgbClr val="1A2E3A"/>
                 </a:solidFill>
@@ -9920,7 +10149,7 @@
               </a:rPr>
               <a:t>truffle 명령어 인식 불가</a:t>
             </a:r>
-            <a:endParaRPr lang="en-US" sz="1300" dirty="0"/>
+            <a:endParaRPr lang="en-US" sz="1200" dirty="0"/>
           </a:p>
         </p:txBody>
       </p:sp>
@@ -9932,8 +10161,8 @@
         </p:nvSpPr>
         <p:spPr>
           <a:xfrm>
-            <a:off x="777240" y="1371600"/>
-            <a:ext cx="3200400" cy="256032"/>
+            <a:off x="749808" y="1316736"/>
+            <a:ext cx="3017520" cy="219456"/>
           </a:xfrm>
           <a:prstGeom prst="rect">
             <a:avLst/>
@@ -9949,7 +10178,7 @@
               <a:buNone/>
             </a:pPr>
             <a:r>
-              <a:rPr lang="en-US" sz="1050" dirty="0">
+              <a:rPr lang="en-US" sz="1000" dirty="0">
                 <a:solidFill>
                   <a:srgbClr val="B04040"/>
                 </a:solidFill>
@@ -9959,50 +10188,20 @@
               </a:rPr>
               <a:t>원인: nvm 버전 미활성화</a:t>
             </a:r>
-            <a:endParaRPr lang="en-US" sz="1050" dirty="0"/>
-          </a:p>
-        </p:txBody>
-      </p:sp>
-      <p:sp>
-        <p:nvSpPr>
-          <p:cNvPr id="9" name="Shape 7"/>
-          <p:cNvSpPr/>
-          <p:nvPr/>
-        </p:nvSpPr>
-        <p:spPr>
-          <a:xfrm>
-            <a:off x="4069080" y="1325880"/>
-            <a:ext cx="0" cy="137160"/>
-          </a:xfrm>
-          <a:prstGeom prst="line">
-            <a:avLst/>
-          </a:prstGeom>
-          <a:noFill/>
-          <a:ln w="19050">
-            <a:solidFill>
-              <a:srgbClr val="02C39A"/>
-            </a:solidFill>
-            <a:prstDash val="solid"/>
-          </a:ln>
-        </p:spPr>
-        <p:txBody>
-          <a:bodyPr/>
-          <a:lstStyle/>
-          <a:p>
-            <a:endParaRPr lang="ko-KR" altLang="en-US"/>
-          </a:p>
-        </p:txBody>
-      </p:sp>
-      <p:sp>
-        <p:nvSpPr>
-          <p:cNvPr id="10" name="Text 8"/>
-          <p:cNvSpPr/>
-          <p:nvPr/>
-        </p:nvSpPr>
-        <p:spPr>
-          <a:xfrm>
-            <a:off x="4206240" y="1042416"/>
-            <a:ext cx="4480560" cy="548640"/>
+            <a:endParaRPr lang="en-US" sz="1000" dirty="0"/>
+          </a:p>
+        </p:txBody>
+      </p:sp>
+      <p:sp>
+        <p:nvSpPr>
+          <p:cNvPr id="9" name="Text 7"/>
+          <p:cNvSpPr/>
+          <p:nvPr/>
+        </p:nvSpPr>
+        <p:spPr>
+          <a:xfrm>
+            <a:off x="3931920" y="1078992"/>
+            <a:ext cx="4846320" cy="411480"/>
           </a:xfrm>
           <a:prstGeom prst="rect">
             <a:avLst/>
@@ -10018,7 +10217,7 @@
               <a:buNone/>
             </a:pPr>
             <a:r>
-              <a:rPr lang="en-US" sz="1100" dirty="0">
+              <a:rPr lang="en-US" sz="1050" dirty="0">
                 <a:solidFill>
                   <a:srgbClr val="1C7293"/>
                 </a:solidFill>
@@ -10028,20 +10227,20 @@
               </a:rPr>
               <a:t>해결: nvm use 18.17.1 &amp;&amp; hash -r</a:t>
             </a:r>
-            <a:endParaRPr lang="en-US" sz="1100" dirty="0"/>
-          </a:p>
-        </p:txBody>
-      </p:sp>
-      <p:sp>
-        <p:nvSpPr>
-          <p:cNvPr id="11" name="Shape 9"/>
-          <p:cNvSpPr/>
-          <p:nvPr/>
-        </p:nvSpPr>
-        <p:spPr>
-          <a:xfrm>
-            <a:off x="274320" y="1792224"/>
-            <a:ext cx="8595360" cy="685800"/>
+            <a:endParaRPr lang="en-US" sz="1050" dirty="0"/>
+          </a:p>
+        </p:txBody>
+      </p:sp>
+      <p:sp>
+        <p:nvSpPr>
+          <p:cNvPr id="10" name="Shape 8"/>
+          <p:cNvSpPr/>
+          <p:nvPr/>
+        </p:nvSpPr>
+        <p:spPr>
+          <a:xfrm>
+            <a:off x="274320" y="1673352"/>
+            <a:ext cx="8595360" cy="576072"/>
           </a:xfrm>
           <a:prstGeom prst="rect">
             <a:avLst/>
@@ -10073,14 +10272,14 @@
       </p:sp>
       <p:sp>
         <p:nvSpPr>
-          <p:cNvPr id="12" name="Shape 10"/>
-          <p:cNvSpPr/>
-          <p:nvPr/>
-        </p:nvSpPr>
-        <p:spPr>
-          <a:xfrm>
-            <a:off x="274320" y="1792224"/>
-            <a:ext cx="411480" cy="685800"/>
+          <p:cNvPr id="11" name="Shape 9"/>
+          <p:cNvSpPr/>
+          <p:nvPr/>
+        </p:nvSpPr>
+        <p:spPr>
+          <a:xfrm>
+            <a:off x="274320" y="1673352"/>
+            <a:ext cx="365760" cy="576072"/>
           </a:xfrm>
           <a:prstGeom prst="rect">
             <a:avLst/>
@@ -10105,14 +10304,14 @@
       </p:sp>
       <p:sp>
         <p:nvSpPr>
-          <p:cNvPr id="13" name="Text 11"/>
-          <p:cNvSpPr/>
-          <p:nvPr/>
-        </p:nvSpPr>
-        <p:spPr>
-          <a:xfrm>
-            <a:off x="274320" y="1956816"/>
-            <a:ext cx="411480" cy="365760"/>
+          <p:cNvPr id="12" name="Text 10"/>
+          <p:cNvSpPr/>
+          <p:nvPr/>
+        </p:nvSpPr>
+        <p:spPr>
+          <a:xfrm>
+            <a:off x="274320" y="1792224"/>
+            <a:ext cx="365760" cy="347472"/>
           </a:xfrm>
           <a:prstGeom prst="rect">
             <a:avLst/>
@@ -10128,7 +10327,7 @@
               <a:buNone/>
             </a:pPr>
             <a:r>
-              <a:rPr lang="en-US" sz="1600" b="1" dirty="0">
+              <a:rPr lang="en-US" sz="1400" b="1" dirty="0">
                 <a:solidFill>
                   <a:srgbClr val="FFFFFF"/>
                 </a:solidFill>
@@ -10138,20 +10337,20 @@
               </a:rPr>
               <a:t>2</a:t>
             </a:r>
-            <a:endParaRPr lang="en-US" sz="1600" dirty="0"/>
-          </a:p>
-        </p:txBody>
-      </p:sp>
-      <p:sp>
-        <p:nvSpPr>
-          <p:cNvPr id="14" name="Text 12"/>
-          <p:cNvSpPr/>
-          <p:nvPr/>
-        </p:nvSpPr>
-        <p:spPr>
-          <a:xfrm>
-            <a:off x="777240" y="1847088"/>
-            <a:ext cx="3200400" cy="320040"/>
+            <a:endParaRPr lang="en-US" sz="1400" dirty="0"/>
+          </a:p>
+        </p:txBody>
+      </p:sp>
+      <p:sp>
+        <p:nvSpPr>
+          <p:cNvPr id="13" name="Text 11"/>
+          <p:cNvSpPr/>
+          <p:nvPr/>
+        </p:nvSpPr>
+        <p:spPr>
+          <a:xfrm>
+            <a:off x="749808" y="1709928"/>
+            <a:ext cx="3017520" cy="274320"/>
           </a:xfrm>
           <a:prstGeom prst="rect">
             <a:avLst/>
@@ -10167,7 +10366,7 @@
               <a:buNone/>
             </a:pPr>
             <a:r>
-              <a:rPr lang="en-US" sz="1300" b="1" dirty="0">
+              <a:rPr lang="en-US" sz="1200" b="1" dirty="0">
                 <a:solidFill>
                   <a:srgbClr val="1A2E3A"/>
                 </a:solidFill>
@@ -10177,20 +10376,20 @@
               </a:rPr>
               <a:t>Block gas limit 초과 배포 실패</a:t>
             </a:r>
-            <a:endParaRPr lang="en-US" sz="1300" dirty="0"/>
-          </a:p>
-        </p:txBody>
-      </p:sp>
-      <p:sp>
-        <p:nvSpPr>
-          <p:cNvPr id="15" name="Text 13"/>
-          <p:cNvSpPr/>
-          <p:nvPr/>
-        </p:nvSpPr>
-        <p:spPr>
-          <a:xfrm>
-            <a:off x="777240" y="2176272"/>
-            <a:ext cx="3200400" cy="256032"/>
+            <a:endParaRPr lang="en-US" sz="1200" dirty="0"/>
+          </a:p>
+        </p:txBody>
+      </p:sp>
+      <p:sp>
+        <p:nvSpPr>
+          <p:cNvPr id="14" name="Text 12"/>
+          <p:cNvSpPr/>
+          <p:nvPr/>
+        </p:nvSpPr>
+        <p:spPr>
+          <a:xfrm>
+            <a:off x="749808" y="2002536"/>
+            <a:ext cx="3017520" cy="219456"/>
           </a:xfrm>
           <a:prstGeom prst="rect">
             <a:avLst/>
@@ -10206,7 +10405,7 @@
               <a:buNone/>
             </a:pPr>
             <a:r>
-              <a:rPr lang="en-US" sz="1050" dirty="0">
+              <a:rPr lang="en-US" sz="1000" dirty="0">
                 <a:solidFill>
                   <a:srgbClr val="B04040"/>
                 </a:solidFill>
@@ -10216,50 +10415,20 @@
               </a:rPr>
               <a:t>원인: gas(6721975) &gt; 블록 한도(4013330)</a:t>
             </a:r>
-            <a:endParaRPr lang="en-US" sz="1050" dirty="0"/>
-          </a:p>
-        </p:txBody>
-      </p:sp>
-      <p:sp>
-        <p:nvSpPr>
-          <p:cNvPr id="16" name="Shape 14"/>
-          <p:cNvSpPr/>
-          <p:nvPr/>
-        </p:nvSpPr>
-        <p:spPr>
-          <a:xfrm>
-            <a:off x="4069080" y="2130552"/>
-            <a:ext cx="0" cy="137160"/>
-          </a:xfrm>
-          <a:prstGeom prst="line">
-            <a:avLst/>
-          </a:prstGeom>
-          <a:noFill/>
-          <a:ln w="19050">
-            <a:solidFill>
-              <a:srgbClr val="02C39A"/>
-            </a:solidFill>
-            <a:prstDash val="solid"/>
-          </a:ln>
-        </p:spPr>
-        <p:txBody>
-          <a:bodyPr/>
-          <a:lstStyle/>
-          <a:p>
-            <a:endParaRPr lang="ko-KR" altLang="en-US"/>
-          </a:p>
-        </p:txBody>
-      </p:sp>
-      <p:sp>
-        <p:nvSpPr>
-          <p:cNvPr id="17" name="Text 15"/>
-          <p:cNvSpPr/>
-          <p:nvPr/>
-        </p:nvSpPr>
-        <p:spPr>
-          <a:xfrm>
-            <a:off x="4206240" y="1847088"/>
-            <a:ext cx="4480560" cy="548640"/>
+            <a:endParaRPr lang="en-US" sz="1000" dirty="0"/>
+          </a:p>
+        </p:txBody>
+      </p:sp>
+      <p:sp>
+        <p:nvSpPr>
+          <p:cNvPr id="15" name="Text 13"/>
+          <p:cNvSpPr/>
+          <p:nvPr/>
+        </p:nvSpPr>
+        <p:spPr>
+          <a:xfrm>
+            <a:off x="3931920" y="1764792"/>
+            <a:ext cx="4846320" cy="411480"/>
           </a:xfrm>
           <a:prstGeom prst="rect">
             <a:avLst/>
@@ -10275,7 +10444,7 @@
               <a:buNone/>
             </a:pPr>
             <a:r>
-              <a:rPr lang="en-US" sz="1100" dirty="0">
+              <a:rPr lang="en-US" sz="1050" dirty="0">
                 <a:solidFill>
                   <a:srgbClr val="1C7293"/>
                 </a:solidFill>
@@ -10285,20 +10454,20 @@
               </a:rPr>
               <a:t>해결: truffle-config.js  gas: 3900000</a:t>
             </a:r>
-            <a:endParaRPr lang="en-US" sz="1100" dirty="0"/>
-          </a:p>
-        </p:txBody>
-      </p:sp>
-      <p:sp>
-        <p:nvSpPr>
-          <p:cNvPr id="18" name="Shape 16"/>
-          <p:cNvSpPr/>
-          <p:nvPr/>
-        </p:nvSpPr>
-        <p:spPr>
-          <a:xfrm>
-            <a:off x="274320" y="2596896"/>
-            <a:ext cx="8595360" cy="685800"/>
+            <a:endParaRPr lang="en-US" sz="1050" dirty="0"/>
+          </a:p>
+        </p:txBody>
+      </p:sp>
+      <p:sp>
+        <p:nvSpPr>
+          <p:cNvPr id="16" name="Shape 14"/>
+          <p:cNvSpPr/>
+          <p:nvPr/>
+        </p:nvSpPr>
+        <p:spPr>
+          <a:xfrm>
+            <a:off x="274320" y="2359152"/>
+            <a:ext cx="8595360" cy="576072"/>
           </a:xfrm>
           <a:prstGeom prst="rect">
             <a:avLst/>
@@ -10330,14 +10499,14 @@
       </p:sp>
       <p:sp>
         <p:nvSpPr>
-          <p:cNvPr id="19" name="Shape 17"/>
-          <p:cNvSpPr/>
-          <p:nvPr/>
-        </p:nvSpPr>
-        <p:spPr>
-          <a:xfrm>
-            <a:off x="274320" y="2596896"/>
-            <a:ext cx="411480" cy="685800"/>
+          <p:cNvPr id="17" name="Shape 15"/>
+          <p:cNvSpPr/>
+          <p:nvPr/>
+        </p:nvSpPr>
+        <p:spPr>
+          <a:xfrm>
+            <a:off x="274320" y="2359152"/>
+            <a:ext cx="365760" cy="576072"/>
           </a:xfrm>
           <a:prstGeom prst="rect">
             <a:avLst/>
@@ -10362,14 +10531,14 @@
       </p:sp>
       <p:sp>
         <p:nvSpPr>
-          <p:cNvPr id="20" name="Text 18"/>
-          <p:cNvSpPr/>
-          <p:nvPr/>
-        </p:nvSpPr>
-        <p:spPr>
-          <a:xfrm>
-            <a:off x="274320" y="2761488"/>
-            <a:ext cx="411480" cy="365760"/>
+          <p:cNvPr id="18" name="Text 16"/>
+          <p:cNvSpPr/>
+          <p:nvPr/>
+        </p:nvSpPr>
+        <p:spPr>
+          <a:xfrm>
+            <a:off x="274320" y="2478024"/>
+            <a:ext cx="365760" cy="347472"/>
           </a:xfrm>
           <a:prstGeom prst="rect">
             <a:avLst/>
@@ -10385,7 +10554,7 @@
               <a:buNone/>
             </a:pPr>
             <a:r>
-              <a:rPr lang="en-US" sz="1600" b="1" dirty="0">
+              <a:rPr lang="en-US" sz="1400" b="1" dirty="0">
                 <a:solidFill>
                   <a:srgbClr val="FFFFFF"/>
                 </a:solidFill>
@@ -10395,20 +10564,20 @@
               </a:rPr>
               <a:t>3</a:t>
             </a:r>
-            <a:endParaRPr lang="en-US" sz="1600" dirty="0"/>
-          </a:p>
-        </p:txBody>
-      </p:sp>
-      <p:sp>
-        <p:nvSpPr>
-          <p:cNvPr id="21" name="Text 19"/>
-          <p:cNvSpPr/>
-          <p:nvPr/>
-        </p:nvSpPr>
-        <p:spPr>
-          <a:xfrm>
-            <a:off x="777240" y="2651760"/>
-            <a:ext cx="3200400" cy="320040"/>
+            <a:endParaRPr lang="en-US" sz="1400" dirty="0"/>
+          </a:p>
+        </p:txBody>
+      </p:sp>
+      <p:sp>
+        <p:nvSpPr>
+          <p:cNvPr id="19" name="Text 17"/>
+          <p:cNvSpPr/>
+          <p:nvPr/>
+        </p:nvSpPr>
+        <p:spPr>
+          <a:xfrm>
+            <a:off x="749808" y="2395728"/>
+            <a:ext cx="3017520" cy="274320"/>
           </a:xfrm>
           <a:prstGeom prst="rect">
             <a:avLst/>
@@ -10424,7 +10593,7 @@
               <a:buNone/>
             </a:pPr>
             <a:r>
-              <a:rPr lang="en-US" sz="1300" b="1" dirty="0">
+              <a:rPr lang="en-US" sz="1200" b="1" dirty="0">
                 <a:solidFill>
                   <a:srgbClr val="1A2E3A"/>
                 </a:solidFill>
@@ -10434,20 +10603,20 @@
               </a:rPr>
               <a:t>EIP-1559 트랜잭션 오류</a:t>
             </a:r>
-            <a:endParaRPr lang="en-US" sz="1300" dirty="0"/>
-          </a:p>
-        </p:txBody>
-      </p:sp>
-      <p:sp>
-        <p:nvSpPr>
-          <p:cNvPr id="22" name="Text 20"/>
-          <p:cNvSpPr/>
-          <p:nvPr/>
-        </p:nvSpPr>
-        <p:spPr>
-          <a:xfrm>
-            <a:off x="777240" y="2980944"/>
-            <a:ext cx="3200400" cy="256032"/>
+            <a:endParaRPr lang="en-US" sz="1200" dirty="0"/>
+          </a:p>
+        </p:txBody>
+      </p:sp>
+      <p:sp>
+        <p:nvSpPr>
+          <p:cNvPr id="20" name="Text 18"/>
+          <p:cNvSpPr/>
+          <p:nvPr/>
+        </p:nvSpPr>
+        <p:spPr>
+          <a:xfrm>
+            <a:off x="749808" y="2688336"/>
+            <a:ext cx="3017520" cy="219456"/>
           </a:xfrm>
           <a:prstGeom prst="rect">
             <a:avLst/>
@@ -10463,7 +10632,7 @@
               <a:buNone/>
             </a:pPr>
             <a:r>
-              <a:rPr lang="en-US" sz="1050" dirty="0">
+              <a:rPr lang="en-US" sz="1000" dirty="0">
                 <a:solidFill>
                   <a:srgbClr val="B04040"/>
                 </a:solidFill>
@@ -10473,50 +10642,20 @@
               </a:rPr>
               <a:t>원인: Geth 1.10 EIP-1559 미지원</a:t>
             </a:r>
-            <a:endParaRPr lang="en-US" sz="1050" dirty="0"/>
-          </a:p>
-        </p:txBody>
-      </p:sp>
-      <p:sp>
-        <p:nvSpPr>
-          <p:cNvPr id="23" name="Shape 21"/>
-          <p:cNvSpPr/>
-          <p:nvPr/>
-        </p:nvSpPr>
-        <p:spPr>
-          <a:xfrm>
-            <a:off x="4069080" y="2935224"/>
-            <a:ext cx="0" cy="137160"/>
-          </a:xfrm>
-          <a:prstGeom prst="line">
-            <a:avLst/>
-          </a:prstGeom>
-          <a:noFill/>
-          <a:ln w="19050">
-            <a:solidFill>
-              <a:srgbClr val="02C39A"/>
-            </a:solidFill>
-            <a:prstDash val="solid"/>
-          </a:ln>
-        </p:spPr>
-        <p:txBody>
-          <a:bodyPr/>
-          <a:lstStyle/>
-          <a:p>
-            <a:endParaRPr lang="ko-KR" altLang="en-US"/>
-          </a:p>
-        </p:txBody>
-      </p:sp>
-      <p:sp>
-        <p:nvSpPr>
-          <p:cNvPr id="24" name="Text 22"/>
-          <p:cNvSpPr/>
-          <p:nvPr/>
-        </p:nvSpPr>
-        <p:spPr>
-          <a:xfrm>
-            <a:off x="4206240" y="2651760"/>
-            <a:ext cx="4480560" cy="548640"/>
+            <a:endParaRPr lang="en-US" sz="1000" dirty="0"/>
+          </a:p>
+        </p:txBody>
+      </p:sp>
+      <p:sp>
+        <p:nvSpPr>
+          <p:cNvPr id="21" name="Text 19"/>
+          <p:cNvSpPr/>
+          <p:nvPr/>
+        </p:nvSpPr>
+        <p:spPr>
+          <a:xfrm>
+            <a:off x="3931920" y="2450592"/>
+            <a:ext cx="4846320" cy="411480"/>
           </a:xfrm>
           <a:prstGeom prst="rect">
             <a:avLst/>
@@ -10532,7 +10671,7 @@
               <a:buNone/>
             </a:pPr>
             <a:r>
-              <a:rPr lang="en-US" sz="1100" dirty="0">
+              <a:rPr lang="en-US" sz="1050" dirty="0">
                 <a:solidFill>
                   <a:srgbClr val="1C7293"/>
                 </a:solidFill>
@@ -10542,20 +10681,20 @@
               </a:rPr>
               <a:t>해결: send()에 gasPrice: "1000000000" 추가</a:t>
             </a:r>
-            <a:endParaRPr lang="en-US" sz="1100" dirty="0"/>
-          </a:p>
-        </p:txBody>
-      </p:sp>
-      <p:sp>
-        <p:nvSpPr>
-          <p:cNvPr id="25" name="Shape 23"/>
-          <p:cNvSpPr/>
-          <p:nvPr/>
-        </p:nvSpPr>
-        <p:spPr>
-          <a:xfrm>
-            <a:off x="274320" y="3401568"/>
-            <a:ext cx="8595360" cy="685800"/>
+            <a:endParaRPr lang="en-US" sz="1050" dirty="0"/>
+          </a:p>
+        </p:txBody>
+      </p:sp>
+      <p:sp>
+        <p:nvSpPr>
+          <p:cNvPr id="22" name="Shape 20"/>
+          <p:cNvSpPr/>
+          <p:nvPr/>
+        </p:nvSpPr>
+        <p:spPr>
+          <a:xfrm>
+            <a:off x="274320" y="3044952"/>
+            <a:ext cx="8595360" cy="576072"/>
           </a:xfrm>
           <a:prstGeom prst="rect">
             <a:avLst/>
@@ -10587,14 +10726,14 @@
       </p:sp>
       <p:sp>
         <p:nvSpPr>
-          <p:cNvPr id="26" name="Shape 24"/>
-          <p:cNvSpPr/>
-          <p:nvPr/>
-        </p:nvSpPr>
-        <p:spPr>
-          <a:xfrm>
-            <a:off x="274320" y="3401568"/>
-            <a:ext cx="411480" cy="685800"/>
+          <p:cNvPr id="23" name="Shape 21"/>
+          <p:cNvSpPr/>
+          <p:nvPr/>
+        </p:nvSpPr>
+        <p:spPr>
+          <a:xfrm>
+            <a:off x="274320" y="3044952"/>
+            <a:ext cx="365760" cy="576072"/>
           </a:xfrm>
           <a:prstGeom prst="rect">
             <a:avLst/>
@@ -10619,14 +10758,14 @@
       </p:sp>
       <p:sp>
         <p:nvSpPr>
-          <p:cNvPr id="27" name="Text 25"/>
-          <p:cNvSpPr/>
-          <p:nvPr/>
-        </p:nvSpPr>
-        <p:spPr>
-          <a:xfrm>
-            <a:off x="274320" y="3566160"/>
-            <a:ext cx="411480" cy="365760"/>
+          <p:cNvPr id="24" name="Text 22"/>
+          <p:cNvSpPr/>
+          <p:nvPr/>
+        </p:nvSpPr>
+        <p:spPr>
+          <a:xfrm>
+            <a:off x="274320" y="3163824"/>
+            <a:ext cx="365760" cy="347472"/>
           </a:xfrm>
           <a:prstGeom prst="rect">
             <a:avLst/>
@@ -10642,7 +10781,7 @@
               <a:buNone/>
             </a:pPr>
             <a:r>
-              <a:rPr lang="en-US" sz="1600" b="1" dirty="0">
+              <a:rPr lang="en-US" sz="1400" b="1" dirty="0">
                 <a:solidFill>
                   <a:srgbClr val="FFFFFF"/>
                 </a:solidFill>
@@ -10652,20 +10791,20 @@
               </a:rPr>
               <a:t>4</a:t>
             </a:r>
-            <a:endParaRPr lang="en-US" sz="1600" dirty="0"/>
-          </a:p>
-        </p:txBody>
-      </p:sp>
-      <p:sp>
-        <p:nvSpPr>
-          <p:cNvPr id="28" name="Text 26"/>
-          <p:cNvSpPr/>
-          <p:nvPr/>
-        </p:nvSpPr>
-        <p:spPr>
-          <a:xfrm>
-            <a:off x="777240" y="3456432"/>
-            <a:ext cx="3200400" cy="320040"/>
+            <a:endParaRPr lang="en-US" sz="1400" dirty="0"/>
+          </a:p>
+        </p:txBody>
+      </p:sp>
+      <p:sp>
+        <p:nvSpPr>
+          <p:cNvPr id="25" name="Text 23"/>
+          <p:cNvSpPr/>
+          <p:nvPr/>
+        </p:nvSpPr>
+        <p:spPr>
+          <a:xfrm>
+            <a:off x="749808" y="3081528"/>
+            <a:ext cx="3017520" cy="274320"/>
           </a:xfrm>
           <a:prstGeom prst="rect">
             <a:avLst/>
@@ -10681,7 +10820,7 @@
               <a:buNone/>
             </a:pPr>
             <a:r>
-              <a:rPr lang="en-US" sz="1300" b="1" dirty="0">
+              <a:rPr lang="en-US" sz="1200" b="1" dirty="0">
                 <a:solidFill>
                   <a:srgbClr val="1A2E3A"/>
                 </a:solidFill>
@@ -10691,20 +10830,20 @@
               </a:rPr>
               <a:t>MetaMask 잘못된 네트워크</a:t>
             </a:r>
-            <a:endParaRPr lang="en-US" sz="1300" dirty="0"/>
-          </a:p>
-        </p:txBody>
-      </p:sp>
-      <p:sp>
-        <p:nvSpPr>
-          <p:cNvPr id="29" name="Text 27"/>
-          <p:cNvSpPr/>
-          <p:nvPr/>
-        </p:nvSpPr>
-        <p:spPr>
-          <a:xfrm>
-            <a:off x="777240" y="3785616"/>
-            <a:ext cx="3200400" cy="256032"/>
+            <a:endParaRPr lang="en-US" sz="1200" dirty="0"/>
+          </a:p>
+        </p:txBody>
+      </p:sp>
+      <p:sp>
+        <p:nvSpPr>
+          <p:cNvPr id="26" name="Text 24"/>
+          <p:cNvSpPr/>
+          <p:nvPr/>
+        </p:nvSpPr>
+        <p:spPr>
+          <a:xfrm>
+            <a:off x="749808" y="3374136"/>
+            <a:ext cx="3017520" cy="219456"/>
           </a:xfrm>
           <a:prstGeom prst="rect">
             <a:avLst/>
@@ -10720,7 +10859,7 @@
               <a:buNone/>
             </a:pPr>
             <a:r>
-              <a:rPr lang="en-US" sz="1050" dirty="0">
+              <a:rPr lang="en-US" sz="1000" dirty="0">
                 <a:solidFill>
                   <a:srgbClr val="B04040"/>
                 </a:solidFill>
@@ -10730,50 +10869,20 @@
               </a:rPr>
               <a:t>원인: Ethereum 메인넷으로 전송</a:t>
             </a:r>
-            <a:endParaRPr lang="en-US" sz="1050" dirty="0"/>
-          </a:p>
-        </p:txBody>
-      </p:sp>
-      <p:sp>
-        <p:nvSpPr>
-          <p:cNvPr id="30" name="Shape 28"/>
-          <p:cNvSpPr/>
-          <p:nvPr/>
-        </p:nvSpPr>
-        <p:spPr>
-          <a:xfrm>
-            <a:off x="4069080" y="3739896"/>
-            <a:ext cx="0" cy="137160"/>
-          </a:xfrm>
-          <a:prstGeom prst="line">
-            <a:avLst/>
-          </a:prstGeom>
-          <a:noFill/>
-          <a:ln w="19050">
-            <a:solidFill>
-              <a:srgbClr val="02C39A"/>
-            </a:solidFill>
-            <a:prstDash val="solid"/>
-          </a:ln>
-        </p:spPr>
-        <p:txBody>
-          <a:bodyPr/>
-          <a:lstStyle/>
-          <a:p>
-            <a:endParaRPr lang="ko-KR" altLang="en-US"/>
-          </a:p>
-        </p:txBody>
-      </p:sp>
-      <p:sp>
-        <p:nvSpPr>
-          <p:cNvPr id="31" name="Text 29"/>
-          <p:cNvSpPr/>
-          <p:nvPr/>
-        </p:nvSpPr>
-        <p:spPr>
-          <a:xfrm>
-            <a:off x="4206240" y="3456432"/>
-            <a:ext cx="4480560" cy="548640"/>
+            <a:endParaRPr lang="en-US" sz="1000" dirty="0"/>
+          </a:p>
+        </p:txBody>
+      </p:sp>
+      <p:sp>
+        <p:nvSpPr>
+          <p:cNvPr id="27" name="Text 25"/>
+          <p:cNvSpPr/>
+          <p:nvPr/>
+        </p:nvSpPr>
+        <p:spPr>
+          <a:xfrm>
+            <a:off x="3931920" y="3136392"/>
+            <a:ext cx="4846320" cy="411480"/>
           </a:xfrm>
           <a:prstGeom prst="rect">
             <a:avLst/>
@@ -10789,7 +10898,7 @@
               <a:buNone/>
             </a:pPr>
             <a:r>
-              <a:rPr lang="en-US" sz="1100" dirty="0">
+              <a:rPr lang="en-US" sz="1050" dirty="0">
                 <a:solidFill>
                   <a:srgbClr val="1C7293"/>
                 </a:solidFill>
@@ -10799,20 +10908,20 @@
               </a:rPr>
               <a:t>해결: wallet_switchEthereumChain으로 자동 전환</a:t>
             </a:r>
-            <a:endParaRPr lang="en-US" sz="1100" dirty="0"/>
-          </a:p>
-        </p:txBody>
-      </p:sp>
-      <p:sp>
-        <p:nvSpPr>
-          <p:cNvPr id="32" name="Shape 30"/>
-          <p:cNvSpPr/>
-          <p:nvPr/>
-        </p:nvSpPr>
-        <p:spPr>
-          <a:xfrm>
-            <a:off x="274320" y="4206240"/>
-            <a:ext cx="8595360" cy="685800"/>
+            <a:endParaRPr lang="en-US" sz="1050" dirty="0"/>
+          </a:p>
+        </p:txBody>
+      </p:sp>
+      <p:sp>
+        <p:nvSpPr>
+          <p:cNvPr id="28" name="Shape 26"/>
+          <p:cNvSpPr/>
+          <p:nvPr/>
+        </p:nvSpPr>
+        <p:spPr>
+          <a:xfrm>
+            <a:off x="274320" y="3730752"/>
+            <a:ext cx="8595360" cy="576072"/>
           </a:xfrm>
           <a:prstGeom prst="rect">
             <a:avLst/>
@@ -10844,14 +10953,14 @@
       </p:sp>
       <p:sp>
         <p:nvSpPr>
-          <p:cNvPr id="33" name="Shape 31"/>
-          <p:cNvSpPr/>
-          <p:nvPr/>
-        </p:nvSpPr>
-        <p:spPr>
-          <a:xfrm>
-            <a:off x="274320" y="4206240"/>
-            <a:ext cx="411480" cy="685800"/>
+          <p:cNvPr id="29" name="Shape 27"/>
+          <p:cNvSpPr/>
+          <p:nvPr/>
+        </p:nvSpPr>
+        <p:spPr>
+          <a:xfrm>
+            <a:off x="274320" y="3730752"/>
+            <a:ext cx="365760" cy="576072"/>
           </a:xfrm>
           <a:prstGeom prst="rect">
             <a:avLst/>
@@ -10876,14 +10985,14 @@
       </p:sp>
       <p:sp>
         <p:nvSpPr>
-          <p:cNvPr id="34" name="Text 32"/>
-          <p:cNvSpPr/>
-          <p:nvPr/>
-        </p:nvSpPr>
-        <p:spPr>
-          <a:xfrm>
-            <a:off x="274320" y="4370832"/>
-            <a:ext cx="411480" cy="365760"/>
+          <p:cNvPr id="30" name="Text 28"/>
+          <p:cNvSpPr/>
+          <p:nvPr/>
+        </p:nvSpPr>
+        <p:spPr>
+          <a:xfrm>
+            <a:off x="274320" y="3849624"/>
+            <a:ext cx="365760" cy="347472"/>
           </a:xfrm>
           <a:prstGeom prst="rect">
             <a:avLst/>
@@ -10899,7 +11008,7 @@
               <a:buNone/>
             </a:pPr>
             <a:r>
-              <a:rPr lang="en-US" sz="1600" b="1" dirty="0">
+              <a:rPr lang="en-US" sz="1400" b="1" dirty="0">
                 <a:solidFill>
                   <a:srgbClr val="FFFFFF"/>
                 </a:solidFill>
@@ -10909,20 +11018,20 @@
               </a:rPr>
               <a:t>5</a:t>
             </a:r>
-            <a:endParaRPr lang="en-US" sz="1600" dirty="0"/>
-          </a:p>
-        </p:txBody>
-      </p:sp>
-      <p:sp>
-        <p:nvSpPr>
-          <p:cNvPr id="35" name="Text 33"/>
-          <p:cNvSpPr/>
-          <p:nvPr/>
-        </p:nvSpPr>
-        <p:spPr>
-          <a:xfrm>
-            <a:off x="777240" y="4261104"/>
-            <a:ext cx="3200400" cy="320040"/>
+            <a:endParaRPr lang="en-US" sz="1400" dirty="0"/>
+          </a:p>
+        </p:txBody>
+      </p:sp>
+      <p:sp>
+        <p:nvSpPr>
+          <p:cNvPr id="31" name="Text 29"/>
+          <p:cNvSpPr/>
+          <p:nvPr/>
+        </p:nvSpPr>
+        <p:spPr>
+          <a:xfrm>
+            <a:off x="749808" y="3767328"/>
+            <a:ext cx="3017520" cy="274320"/>
           </a:xfrm>
           <a:prstGeom prst="rect">
             <a:avLst/>
@@ -10938,7 +11047,7 @@
               <a:buNone/>
             </a:pPr>
             <a:r>
-              <a:rPr lang="en-US" sz="1300" b="1" dirty="0">
+              <a:rPr lang="en-US" sz="1200" b="1" dirty="0">
                 <a:solidFill>
                   <a:srgbClr val="1A2E3A"/>
                 </a:solidFill>
@@ -10946,22 +11055,22 @@
                 <a:ea typeface="Arial Black" pitchFamily="34" charset="-122"/>
                 <a:cs typeface="Arial Black" pitchFamily="34" charset="-120"/>
               </a:rPr>
-              <a:t>경매 종료 EVM Revert</a:t>
-            </a:r>
-            <a:endParaRPr lang="en-US" sz="1300" dirty="0"/>
-          </a:p>
-        </p:txBody>
-      </p:sp>
-      <p:sp>
-        <p:nvSpPr>
-          <p:cNvPr id="36" name="Text 34"/>
-          <p:cNvSpPr/>
-          <p:nvPr/>
-        </p:nvSpPr>
-        <p:spPr>
-          <a:xfrm>
-            <a:off x="777240" y="4590288"/>
-            <a:ext cx="3200400" cy="256032"/>
+              <a:t>Node1·Node2 잦은 연결 끊김</a:t>
+            </a:r>
+            <a:endParaRPr lang="en-US" sz="1200" dirty="0"/>
+          </a:p>
+        </p:txBody>
+      </p:sp>
+      <p:sp>
+        <p:nvSpPr>
+          <p:cNvPr id="32" name="Text 30"/>
+          <p:cNvSpPr/>
+          <p:nvPr/>
+        </p:nvSpPr>
+        <p:spPr>
+          <a:xfrm>
+            <a:off x="749808" y="4059936"/>
+            <a:ext cx="3017520" cy="219456"/>
           </a:xfrm>
           <a:prstGeom prst="rect">
             <a:avLst/>
@@ -10977,7 +11086,7 @@
               <a:buNone/>
             </a:pPr>
             <a:r>
-              <a:rPr lang="en-US" sz="1050" dirty="0">
+              <a:rPr lang="en-US" sz="1000" dirty="0">
                 <a:solidFill>
                   <a:srgbClr val="B04040"/>
                 </a:solidFill>
@@ -10985,7 +11094,46 @@
                 <a:ea typeface="Calibri" pitchFamily="34" charset="-122"/>
                 <a:cs typeface="Calibri" pitchFamily="34" charset="-120"/>
               </a:rPr>
-              <a:t>원인: 경매 시간(300초) 미경과</a:t>
+              <a:t>원인: Unclean shutdown → 체인 포크 발생</a:t>
+            </a:r>
+            <a:endParaRPr lang="en-US" sz="1000" dirty="0"/>
+          </a:p>
+        </p:txBody>
+      </p:sp>
+      <p:sp>
+        <p:nvSpPr>
+          <p:cNvPr id="33" name="Text 31"/>
+          <p:cNvSpPr/>
+          <p:nvPr/>
+        </p:nvSpPr>
+        <p:spPr>
+          <a:xfrm>
+            <a:off x="3931920" y="3822192"/>
+            <a:ext cx="4846320" cy="411480"/>
+          </a:xfrm>
+          <a:prstGeom prst="rect">
+            <a:avLst/>
+          </a:prstGeom>
+          <a:noFill/>
+          <a:ln/>
+        </p:spPr>
+        <p:txBody>
+          <a:bodyPr wrap="square" lIns="0" tIns="0" rIns="0" bIns="0" rtlCol="0" anchor="ctr"/>
+          <a:lstStyle/>
+          <a:p>
+            <a:pPr marL="0" indent="0">
+              <a:buNone/>
+            </a:pPr>
+            <a:r>
+              <a:rPr lang="en-US" sz="1050" dirty="0">
+                <a:solidFill>
+                  <a:srgbClr val="1C7293"/>
+                </a:solidFill>
+                <a:latin typeface="Consolas" pitchFamily="34" charset="0"/>
+                <a:ea typeface="Consolas" pitchFamily="34" charset="-122"/>
+                <a:cs typeface="Consolas" pitchFamily="34" charset="-120"/>
+              </a:rPr>
+              <a:t>해결: Node2 chaindata 초기화 + static-nodes.json 설정</a:t>
             </a:r>
             <a:endParaRPr lang="en-US" sz="1050" dirty="0"/>
           </a:p>
@@ -10993,25 +11141,34 @@
       </p:sp>
       <p:sp>
         <p:nvSpPr>
-          <p:cNvPr id="37" name="Shape 35"/>
-          <p:cNvSpPr/>
-          <p:nvPr/>
-        </p:nvSpPr>
-        <p:spPr>
-          <a:xfrm>
-            <a:off x="4069080" y="4544568"/>
-            <a:ext cx="0" cy="137160"/>
-          </a:xfrm>
-          <a:prstGeom prst="line">
-            <a:avLst/>
-          </a:prstGeom>
-          <a:noFill/>
-          <a:ln w="19050">
+          <p:cNvPr id="34" name="Shape 32"/>
+          <p:cNvSpPr/>
+          <p:nvPr/>
+        </p:nvSpPr>
+        <p:spPr>
+          <a:xfrm>
+            <a:off x="274320" y="4416552"/>
+            <a:ext cx="8595360" cy="576072"/>
+          </a:xfrm>
+          <a:prstGeom prst="rect">
+            <a:avLst/>
+          </a:prstGeom>
+          <a:solidFill>
+            <a:srgbClr val="FFFFFF"/>
+          </a:solidFill>
+          <a:ln w="12700">
             <a:solidFill>
-              <a:srgbClr val="02C39A"/>
+              <a:srgbClr val="D0E8F5"/>
             </a:solidFill>
             <a:prstDash val="solid"/>
           </a:ln>
+          <a:effectLst>
+            <a:outerShdw blurRad="76200" dist="25400" dir="8100000" algn="bl" rotWithShape="0">
+              <a:srgbClr val="000000">
+                <a:alpha val="13000"/>
+              </a:srgbClr>
+            </a:outerShdw>
+          </a:effectLst>
         </p:spPr>
         <p:txBody>
           <a:bodyPr/>
@@ -11023,14 +11180,124 @@
       </p:sp>
       <p:sp>
         <p:nvSpPr>
+          <p:cNvPr id="35" name="Shape 33"/>
+          <p:cNvSpPr/>
+          <p:nvPr/>
+        </p:nvSpPr>
+        <p:spPr>
+          <a:xfrm>
+            <a:off x="274320" y="4416552"/>
+            <a:ext cx="365760" cy="576072"/>
+          </a:xfrm>
+          <a:prstGeom prst="rect">
+            <a:avLst/>
+          </a:prstGeom>
+          <a:solidFill>
+            <a:srgbClr val="1C7293"/>
+          </a:solidFill>
+          <a:ln w="12700">
+            <a:solidFill>
+              <a:srgbClr val="1C7293"/>
+            </a:solidFill>
+            <a:prstDash val="solid"/>
+          </a:ln>
+        </p:spPr>
+        <p:txBody>
+          <a:bodyPr/>
+          <a:lstStyle/>
+          <a:p>
+            <a:endParaRPr lang="ko-KR" altLang="en-US"/>
+          </a:p>
+        </p:txBody>
+      </p:sp>
+      <p:sp>
+        <p:nvSpPr>
+          <p:cNvPr id="36" name="Text 34"/>
+          <p:cNvSpPr/>
+          <p:nvPr/>
+        </p:nvSpPr>
+        <p:spPr>
+          <a:xfrm>
+            <a:off x="274320" y="4535424"/>
+            <a:ext cx="365760" cy="347472"/>
+          </a:xfrm>
+          <a:prstGeom prst="rect">
+            <a:avLst/>
+          </a:prstGeom>
+          <a:noFill/>
+          <a:ln/>
+        </p:spPr>
+        <p:txBody>
+          <a:bodyPr wrap="square" lIns="0" tIns="0" rIns="0" bIns="0" rtlCol="0" anchor="ctr"/>
+          <a:lstStyle/>
+          <a:p>
+            <a:pPr marL="0" indent="0" algn="ctr">
+              <a:buNone/>
+            </a:pPr>
+            <a:r>
+              <a:rPr lang="en-US" sz="1400" b="1" dirty="0">
+                <a:solidFill>
+                  <a:srgbClr val="FFFFFF"/>
+                </a:solidFill>
+                <a:latin typeface="Arial Black" pitchFamily="34" charset="0"/>
+                <a:ea typeface="Arial Black" pitchFamily="34" charset="-122"/>
+                <a:cs typeface="Arial Black" pitchFamily="34" charset="-120"/>
+              </a:rPr>
+              <a:t>6</a:t>
+            </a:r>
+            <a:endParaRPr lang="en-US" sz="1400" dirty="0"/>
+          </a:p>
+        </p:txBody>
+      </p:sp>
+      <p:sp>
+        <p:nvSpPr>
+          <p:cNvPr id="37" name="Text 35"/>
+          <p:cNvSpPr/>
+          <p:nvPr/>
+        </p:nvSpPr>
+        <p:spPr>
+          <a:xfrm>
+            <a:off x="749808" y="4453128"/>
+            <a:ext cx="3017520" cy="274320"/>
+          </a:xfrm>
+          <a:prstGeom prst="rect">
+            <a:avLst/>
+          </a:prstGeom>
+          <a:noFill/>
+          <a:ln/>
+        </p:spPr>
+        <p:txBody>
+          <a:bodyPr wrap="square" lIns="0" tIns="0" rIns="0" bIns="0" rtlCol="0" anchor="ctr"/>
+          <a:lstStyle/>
+          <a:p>
+            <a:pPr marL="0" indent="0">
+              <a:buNone/>
+            </a:pPr>
+            <a:r>
+              <a:rPr lang="en-US" sz="1200" b="1" dirty="0">
+                <a:solidFill>
+                  <a:srgbClr val="1A2E3A"/>
+                </a:solidFill>
+                <a:latin typeface="Arial Black" pitchFamily="34" charset="0"/>
+                <a:ea typeface="Arial Black" pitchFamily="34" charset="-122"/>
+                <a:cs typeface="Arial Black" pitchFamily="34" charset="-120"/>
+              </a:rPr>
+              <a:t>경매 종료·입찰 EVM Revert</a:t>
+            </a:r>
+            <a:endParaRPr lang="en-US" sz="1200" dirty="0"/>
+          </a:p>
+        </p:txBody>
+      </p:sp>
+      <p:sp>
+        <p:nvSpPr>
           <p:cNvPr id="38" name="Text 36"/>
           <p:cNvSpPr/>
           <p:nvPr/>
         </p:nvSpPr>
         <p:spPr>
           <a:xfrm>
-            <a:off x="4206240" y="4261104"/>
-            <a:ext cx="4480560" cy="548640"/>
+            <a:off x="749808" y="4745736"/>
+            <a:ext cx="3017520" cy="219456"/>
           </a:xfrm>
           <a:prstGeom prst="rect">
             <a:avLst/>
@@ -11046,7 +11313,46 @@
               <a:buNone/>
             </a:pPr>
             <a:r>
-              <a:rPr lang="en-US" sz="1100" dirty="0">
+              <a:rPr lang="en-US" sz="1000" dirty="0">
+                <a:solidFill>
+                  <a:srgbClr val="B04040"/>
+                </a:solidFill>
+                <a:latin typeface="Calibri" pitchFamily="34" charset="0"/>
+                <a:ea typeface="Calibri" pitchFamily="34" charset="-122"/>
+                <a:cs typeface="Calibri" pitchFamily="34" charset="-120"/>
+              </a:rPr>
+              <a:t>원인: 경매 시간 미경과 또는 이미 만료됨</a:t>
+            </a:r>
+            <a:endParaRPr lang="en-US" sz="1000" dirty="0"/>
+          </a:p>
+        </p:txBody>
+      </p:sp>
+      <p:sp>
+        <p:nvSpPr>
+          <p:cNvPr id="39" name="Text 37"/>
+          <p:cNvSpPr/>
+          <p:nvPr/>
+        </p:nvSpPr>
+        <p:spPr>
+          <a:xfrm>
+            <a:off x="3931920" y="4507992"/>
+            <a:ext cx="4846320" cy="411480"/>
+          </a:xfrm>
+          <a:prstGeom prst="rect">
+            <a:avLst/>
+          </a:prstGeom>
+          <a:noFill/>
+          <a:ln/>
+        </p:spPr>
+        <p:txBody>
+          <a:bodyPr wrap="square" lIns="0" tIns="0" rIns="0" bIns="0" rtlCol="0" anchor="ctr"/>
+          <a:lstStyle/>
+          <a:p>
+            <a:pPr marL="0" indent="0">
+              <a:buNone/>
+            </a:pPr>
+            <a:r>
+              <a:rPr lang="en-US" sz="1050" dirty="0">
                 <a:solidFill>
                   <a:srgbClr val="1C7293"/>
                 </a:solidFill>
@@ -11054,9 +11360,9 @@
                 <a:ea typeface="Consolas" pitchFamily="34" charset="-122"/>
                 <a:cs typeface="Consolas" pitchFamily="34" charset="-120"/>
               </a:rPr>
-              <a:t>해결: 경매 종료 시각 이후에 endAuction 호출</a:t>
-            </a:r>
-            <a:endParaRPr lang="en-US" sz="1100" dirty="0"/>
+              <a:t>해결: 경매 시간 300초 이상 설정 / 시간 확인 후 호출</a:t>
+            </a:r>
+            <a:endParaRPr lang="en-US" sz="1050" dirty="0"/>
           </a:p>
         </p:txBody>
       </p:sp>

</xml_diff>